<commit_message>
Fix templates. Fix finish text in different languages.
</commit_message>
<xml_diff>
--- a/make_presentation/templates/templates/flow/_10.pptx
+++ b/make_presentation/templates/templates/flow/_10.pptx
@@ -69,20 +69,17 @@
             <a:noAutofit/>
           </a:bodyPr>
           <a:p>
-            <a:r>
-              <a:rPr b="0" lang="en-US" sz="1800" spc="-1" strike="noStrike">
-                <a:solidFill>
-                  <a:srgbClr val="000000"/>
-                </a:solidFill>
-                <a:latin typeface="Calibri"/>
+            <a:pPr algn="ctr">
+              <a:buNone/>
+            </a:pPr>
+            <a:r>
+              <a:rPr b="0" lang="en-US" sz="4400" spc="-1" strike="noStrike">
+                <a:latin typeface="Arial"/>
               </a:rPr>
               <a:t>Click to move the slide</a:t>
             </a:r>
-            <a:endParaRPr b="0" lang="en-US" sz="1800" spc="-1" strike="noStrike">
-              <a:solidFill>
-                <a:srgbClr val="000000"/>
-              </a:solidFill>
-              <a:latin typeface="Calibri"/>
+            <a:endParaRPr b="0" lang="en-US" sz="4400" spc="-1" strike="noStrike">
+              <a:latin typeface="Arial"/>
             </a:endParaRPr>
           </a:p>
         </p:txBody>
@@ -304,7 +301,7 @@
             <a:pPr algn="r">
               <a:buNone/>
             </a:pPr>
-            <a:fld id="{A24CA6B0-61A6-48D7-95C3-0E5D768E4240}" type="slidenum">
+            <a:fld id="{DCA9E830-36AB-41B6-8BCE-41C2A5B1ED0E}" type="slidenum">
               <a:rPr b="0" lang="en-US" sz="1400" spc="-1" strike="noStrike">
                 <a:latin typeface="Times New Roman"/>
               </a:rPr>
@@ -341,7 +338,7 @@
       </p:grpSpPr>
       <p:sp>
         <p:nvSpPr>
-          <p:cNvPr id="154" name="PlaceHolder 1"/>
+          <p:cNvPr id="153" name="PlaceHolder 1"/>
           <p:cNvSpPr>
             <a:spLocks noGrp="1"/>
           </p:cNvSpPr>
@@ -352,19 +349,19 @@
         <p:spPr>
           <a:xfrm>
             <a:off x="685800" y="1143000"/>
-            <a:ext cx="5486040" cy="3085920"/>
-          </a:xfrm>
-          <a:prstGeom prst="rect">
-            <a:avLst/>
-          </a:prstGeom>
-          <a:ln w="0">
-            <a:noFill/>
-          </a:ln>
-        </p:spPr>
-      </p:sp>
-      <p:sp>
-        <p:nvSpPr>
-          <p:cNvPr id="155" name="PlaceHolder 2"/>
+            <a:ext cx="5485680" cy="3085560"/>
+          </a:xfrm>
+          <a:prstGeom prst="rect">
+            <a:avLst/>
+          </a:prstGeom>
+          <a:ln w="0">
+            <a:noFill/>
+          </a:ln>
+        </p:spPr>
+      </p:sp>
+      <p:sp>
+        <p:nvSpPr>
+          <p:cNvPr id="154" name="PlaceHolder 2"/>
           <p:cNvSpPr>
             <a:spLocks noGrp="1"/>
           </p:cNvSpPr>
@@ -375,18 +372,18 @@
         <p:spPr>
           <a:xfrm>
             <a:off x="685800" y="4400640"/>
-            <a:ext cx="5486040" cy="3600000"/>
-          </a:xfrm>
-          <a:prstGeom prst="rect">
-            <a:avLst/>
-          </a:prstGeom>
-          <a:noFill/>
-          <a:ln w="0">
-            <a:noFill/>
-          </a:ln>
-        </p:spPr>
-        <p:txBody>
-          <a:bodyPr anchor="t">
+            <a:ext cx="5485680" cy="3599640"/>
+          </a:xfrm>
+          <a:prstGeom prst="rect">
+            <a:avLst/>
+          </a:prstGeom>
+          <a:noFill/>
+          <a:ln w="0">
+            <a:noFill/>
+          </a:ln>
+        </p:spPr>
+        <p:txBody>
+          <a:bodyPr lIns="0" rIns="0" tIns="0" bIns="0" anchor="t">
             <a:noAutofit/>
           </a:bodyPr>
           <a:p>
@@ -398,7 +395,7 @@
       </p:sp>
       <p:sp>
         <p:nvSpPr>
-          <p:cNvPr id="156" name="PlaceHolder 3"/>
+          <p:cNvPr id="155" name="PlaceHolder 3"/>
           <p:cNvSpPr>
             <a:spLocks noGrp="1"/>
           </p:cNvSpPr>
@@ -409,18 +406,18 @@
         <p:spPr>
           <a:xfrm>
             <a:off x="3884760" y="8685360"/>
-            <a:ext cx="2971440" cy="458280"/>
-          </a:xfrm>
-          <a:prstGeom prst="rect">
-            <a:avLst/>
-          </a:prstGeom>
-          <a:noFill/>
-          <a:ln w="0">
-            <a:noFill/>
-          </a:ln>
-        </p:spPr>
-        <p:txBody>
-          <a:bodyPr anchor="b">
+            <a:ext cx="2971080" cy="457920"/>
+          </a:xfrm>
+          <a:prstGeom prst="rect">
+            <a:avLst/>
+          </a:prstGeom>
+          <a:noFill/>
+          <a:ln w="0">
+            <a:noFill/>
+          </a:ln>
+        </p:spPr>
+        <p:txBody>
+          <a:bodyPr lIns="0" rIns="0" tIns="0" bIns="0" anchor="b">
             <a:noAutofit/>
           </a:bodyPr>
           <a:lstStyle>
@@ -441,7 +438,7 @@
               </a:lnSpc>
               <a:buNone/>
             </a:pPr>
-            <a:fld id="{45C3388F-5D56-446E-9415-C0DFBC940208}" type="slidenum">
+            <a:fld id="{76EC39D0-99C5-43D3-BB47-2D1178CF3F86}" type="slidenum">
               <a:rPr b="0" lang="ru-RU" sz="1200" spc="-1" strike="noStrike">
                 <a:latin typeface="Times New Roman"/>
               </a:rPr>
@@ -477,7 +474,7 @@
       </p:grpSpPr>
       <p:sp>
         <p:nvSpPr>
-          <p:cNvPr id="157" name="PlaceHolder 1"/>
+          <p:cNvPr id="156" name="PlaceHolder 1"/>
           <p:cNvSpPr>
             <a:spLocks noGrp="1"/>
           </p:cNvSpPr>
@@ -488,19 +485,19 @@
         <p:spPr>
           <a:xfrm>
             <a:off x="685800" y="1143000"/>
-            <a:ext cx="5486040" cy="3085920"/>
-          </a:xfrm>
-          <a:prstGeom prst="rect">
-            <a:avLst/>
-          </a:prstGeom>
-          <a:ln w="0">
-            <a:noFill/>
-          </a:ln>
-        </p:spPr>
-      </p:sp>
-      <p:sp>
-        <p:nvSpPr>
-          <p:cNvPr id="158" name="PlaceHolder 2"/>
+            <a:ext cx="5485680" cy="3085560"/>
+          </a:xfrm>
+          <a:prstGeom prst="rect">
+            <a:avLst/>
+          </a:prstGeom>
+          <a:ln w="0">
+            <a:noFill/>
+          </a:ln>
+        </p:spPr>
+      </p:sp>
+      <p:sp>
+        <p:nvSpPr>
+          <p:cNvPr id="157" name="PlaceHolder 2"/>
           <p:cNvSpPr>
             <a:spLocks noGrp="1"/>
           </p:cNvSpPr>
@@ -511,18 +508,18 @@
         <p:spPr>
           <a:xfrm>
             <a:off x="685800" y="4400640"/>
-            <a:ext cx="5486040" cy="3600000"/>
-          </a:xfrm>
-          <a:prstGeom prst="rect">
-            <a:avLst/>
-          </a:prstGeom>
-          <a:noFill/>
-          <a:ln w="0">
-            <a:noFill/>
-          </a:ln>
-        </p:spPr>
-        <p:txBody>
-          <a:bodyPr anchor="t">
+            <a:ext cx="5485680" cy="3599640"/>
+          </a:xfrm>
+          <a:prstGeom prst="rect">
+            <a:avLst/>
+          </a:prstGeom>
+          <a:noFill/>
+          <a:ln w="0">
+            <a:noFill/>
+          </a:ln>
+        </p:spPr>
+        <p:txBody>
+          <a:bodyPr lIns="0" rIns="0" tIns="0" bIns="0" anchor="t">
             <a:noAutofit/>
           </a:bodyPr>
           <a:p>
@@ -534,7 +531,7 @@
       </p:sp>
       <p:sp>
         <p:nvSpPr>
-          <p:cNvPr id="159" name="PlaceHolder 3"/>
+          <p:cNvPr id="158" name="PlaceHolder 3"/>
           <p:cNvSpPr>
             <a:spLocks noGrp="1"/>
           </p:cNvSpPr>
@@ -545,18 +542,18 @@
         <p:spPr>
           <a:xfrm>
             <a:off x="3884760" y="8685360"/>
-            <a:ext cx="2971440" cy="458280"/>
-          </a:xfrm>
-          <a:prstGeom prst="rect">
-            <a:avLst/>
-          </a:prstGeom>
-          <a:noFill/>
-          <a:ln w="0">
-            <a:noFill/>
-          </a:ln>
-        </p:spPr>
-        <p:txBody>
-          <a:bodyPr anchor="b">
+            <a:ext cx="2971080" cy="457920"/>
+          </a:xfrm>
+          <a:prstGeom prst="rect">
+            <a:avLst/>
+          </a:prstGeom>
+          <a:noFill/>
+          <a:ln w="0">
+            <a:noFill/>
+          </a:ln>
+        </p:spPr>
+        <p:txBody>
+          <a:bodyPr lIns="0" rIns="0" tIns="0" bIns="0" anchor="b">
             <a:noAutofit/>
           </a:bodyPr>
           <a:lstStyle>
@@ -577,7 +574,7 @@
               </a:lnSpc>
               <a:buNone/>
             </a:pPr>
-            <a:fld id="{97F8E267-C6B0-45D2-97D2-F771C65F704B}" type="slidenum">
+            <a:fld id="{B908E06C-C341-4385-B1E5-64174C3AC7D1}" type="slidenum">
               <a:rPr b="0" lang="ru-RU" sz="1200" spc="-1" strike="noStrike">
                 <a:latin typeface="Times New Roman"/>
               </a:rPr>
@@ -613,7 +610,7 @@
       </p:grpSpPr>
       <p:sp>
         <p:nvSpPr>
-          <p:cNvPr id="160" name="PlaceHolder 1"/>
+          <p:cNvPr id="159" name="PlaceHolder 1"/>
           <p:cNvSpPr>
             <a:spLocks noGrp="1"/>
           </p:cNvSpPr>
@@ -624,19 +621,19 @@
         <p:spPr>
           <a:xfrm>
             <a:off x="685800" y="1143000"/>
-            <a:ext cx="5486040" cy="3085920"/>
-          </a:xfrm>
-          <a:prstGeom prst="rect">
-            <a:avLst/>
-          </a:prstGeom>
-          <a:ln w="0">
-            <a:noFill/>
-          </a:ln>
-        </p:spPr>
-      </p:sp>
-      <p:sp>
-        <p:nvSpPr>
-          <p:cNvPr id="161" name="PlaceHolder 2"/>
+            <a:ext cx="5485680" cy="3085560"/>
+          </a:xfrm>
+          <a:prstGeom prst="rect">
+            <a:avLst/>
+          </a:prstGeom>
+          <a:ln w="0">
+            <a:noFill/>
+          </a:ln>
+        </p:spPr>
+      </p:sp>
+      <p:sp>
+        <p:nvSpPr>
+          <p:cNvPr id="160" name="PlaceHolder 2"/>
           <p:cNvSpPr>
             <a:spLocks noGrp="1"/>
           </p:cNvSpPr>
@@ -647,18 +644,18 @@
         <p:spPr>
           <a:xfrm>
             <a:off x="685800" y="4400640"/>
-            <a:ext cx="5486040" cy="3600000"/>
-          </a:xfrm>
-          <a:prstGeom prst="rect">
-            <a:avLst/>
-          </a:prstGeom>
-          <a:noFill/>
-          <a:ln w="0">
-            <a:noFill/>
-          </a:ln>
-        </p:spPr>
-        <p:txBody>
-          <a:bodyPr anchor="t">
+            <a:ext cx="5485680" cy="3599640"/>
+          </a:xfrm>
+          <a:prstGeom prst="rect">
+            <a:avLst/>
+          </a:prstGeom>
+          <a:noFill/>
+          <a:ln w="0">
+            <a:noFill/>
+          </a:ln>
+        </p:spPr>
+        <p:txBody>
+          <a:bodyPr lIns="0" rIns="0" tIns="0" bIns="0" anchor="t">
             <a:noAutofit/>
           </a:bodyPr>
           <a:p>
@@ -670,7 +667,7 @@
       </p:sp>
       <p:sp>
         <p:nvSpPr>
-          <p:cNvPr id="162" name="PlaceHolder 3"/>
+          <p:cNvPr id="161" name="PlaceHolder 3"/>
           <p:cNvSpPr>
             <a:spLocks noGrp="1"/>
           </p:cNvSpPr>
@@ -681,18 +678,18 @@
         <p:spPr>
           <a:xfrm>
             <a:off x="3884760" y="8685360"/>
-            <a:ext cx="2971440" cy="458280"/>
-          </a:xfrm>
-          <a:prstGeom prst="rect">
-            <a:avLst/>
-          </a:prstGeom>
-          <a:noFill/>
-          <a:ln w="0">
-            <a:noFill/>
-          </a:ln>
-        </p:spPr>
-        <p:txBody>
-          <a:bodyPr anchor="b">
+            <a:ext cx="2971080" cy="457920"/>
+          </a:xfrm>
+          <a:prstGeom prst="rect">
+            <a:avLst/>
+          </a:prstGeom>
+          <a:noFill/>
+          <a:ln w="0">
+            <a:noFill/>
+          </a:ln>
+        </p:spPr>
+        <p:txBody>
+          <a:bodyPr lIns="0" rIns="0" tIns="0" bIns="0" anchor="b">
             <a:noAutofit/>
           </a:bodyPr>
           <a:lstStyle>
@@ -713,7 +710,7 @@
               </a:lnSpc>
               <a:buNone/>
             </a:pPr>
-            <a:fld id="{91D48D1D-8B37-4E04-8BA6-17597C741B6F}" type="slidenum">
+            <a:fld id="{A3F61DC9-2889-46FF-B153-0BDC981735D9}" type="slidenum">
               <a:rPr b="0" lang="ru-RU" sz="1200" spc="-1" strike="noStrike">
                 <a:latin typeface="Times New Roman"/>
               </a:rPr>
@@ -754,7 +751,7 @@
             <a:spLocks noGrp="1"/>
           </p:cNvSpPr>
           <p:nvPr>
-            <p:ph type="ftr" idx="2"/>
+            <p:ph type="ftr" idx="1"/>
           </p:nvPr>
         </p:nvSpPr>
         <p:spPr/>
@@ -774,14 +771,14 @@
             <a:spLocks noGrp="1"/>
           </p:cNvSpPr>
           <p:nvPr>
-            <p:ph type="sldNum" idx="3"/>
+            <p:ph type="sldNum" idx="2"/>
           </p:nvPr>
         </p:nvSpPr>
         <p:spPr/>
         <p:txBody>
           <a:bodyPr/>
           <a:p>
-            <a:fld id="{6DD66AF9-2B3A-436B-AB06-1D68FBACCBD7}" type="slidenum">
+            <a:fld id="{6C0DD296-44C5-42F7-94C9-8492996FFA8D}" type="slidenum">
               <a:t>&lt;#&gt;</a:t>
             </a:fld>
           </a:p>
@@ -794,7 +791,7 @@
             <a:spLocks noGrp="1"/>
           </p:cNvSpPr>
           <p:nvPr>
-            <p:ph type="dt" idx="1"/>
+            <p:ph type="dt" idx="3"/>
           </p:nvPr>
         </p:nvSpPr>
         <p:spPr/>
@@ -843,7 +840,7 @@
         <p:spPr>
           <a:xfrm>
             <a:off x="1143000" y="841680"/>
-            <a:ext cx="6857640" cy="1790280"/>
+            <a:ext cx="6857280" cy="1789920"/>
           </a:xfrm>
           <a:prstGeom prst="rect">
             <a:avLst/>
@@ -858,11 +855,11 @@
             <a:noAutofit/>
           </a:bodyPr>
           <a:p>
-            <a:endParaRPr b="0" lang="en-US" sz="1800" spc="-1" strike="noStrike">
-              <a:solidFill>
-                <a:srgbClr val="000000"/>
-              </a:solidFill>
-              <a:latin typeface="Calibri"/>
+            <a:pPr algn="ctr">
+              <a:buNone/>
+            </a:pPr>
+            <a:endParaRPr b="0" lang="en-US" sz="4400" spc="-1" strike="noStrike">
+              <a:latin typeface="Arial"/>
             </a:endParaRPr>
           </a:p>
         </p:txBody>
@@ -895,20 +892,8 @@
             <a:normAutofit/>
           </a:bodyPr>
           <a:p>
-            <a:pPr>
-              <a:lnSpc>
-                <a:spcPct val="90000"/>
-              </a:lnSpc>
-              <a:spcBef>
-                <a:spcPts val="1417"/>
-              </a:spcBef>
-              <a:buNone/>
-            </a:pPr>
-            <a:endParaRPr b="0" lang="en-US" sz="2100" spc="-1" strike="noStrike">
-              <a:solidFill>
-                <a:srgbClr val="000000"/>
-              </a:solidFill>
-              <a:latin typeface="Calibri"/>
+            <a:endParaRPr b="0" lang="en-US" sz="3200" spc="-1" strike="noStrike">
+              <a:latin typeface="Arial"/>
             </a:endParaRPr>
           </a:p>
         </p:txBody>
@@ -941,20 +926,8 @@
             <a:normAutofit/>
           </a:bodyPr>
           <a:p>
-            <a:pPr>
-              <a:lnSpc>
-                <a:spcPct val="90000"/>
-              </a:lnSpc>
-              <a:spcBef>
-                <a:spcPts val="1417"/>
-              </a:spcBef>
-              <a:buNone/>
-            </a:pPr>
-            <a:endParaRPr b="0" lang="en-US" sz="2100" spc="-1" strike="noStrike">
-              <a:solidFill>
-                <a:srgbClr val="000000"/>
-              </a:solidFill>
-              <a:latin typeface="Calibri"/>
+            <a:endParaRPr b="0" lang="en-US" sz="3200" spc="-1" strike="noStrike">
+              <a:latin typeface="Arial"/>
             </a:endParaRPr>
           </a:p>
         </p:txBody>
@@ -966,7 +939,7 @@
             <a:spLocks noGrp="1"/>
           </p:cNvSpPr>
           <p:nvPr>
-            <p:ph type="ftr" idx="2"/>
+            <p:ph type="ftr" idx="1"/>
           </p:nvPr>
         </p:nvSpPr>
         <p:spPr/>
@@ -986,14 +959,14 @@
             <a:spLocks noGrp="1"/>
           </p:cNvSpPr>
           <p:nvPr>
-            <p:ph type="sldNum" idx="3"/>
+            <p:ph type="sldNum" idx="2"/>
           </p:nvPr>
         </p:nvSpPr>
         <p:spPr/>
         <p:txBody>
           <a:bodyPr/>
           <a:p>
-            <a:fld id="{EA38439E-3D3C-471A-B584-BB839632EABD}" type="slidenum">
+            <a:fld id="{E21ED507-EFFF-4B57-BF4F-BC71C0229F9B}" type="slidenum">
               <a:t>&lt;#&gt;</a:t>
             </a:fld>
           </a:p>
@@ -1006,7 +979,7 @@
             <a:spLocks noGrp="1"/>
           </p:cNvSpPr>
           <p:nvPr>
-            <p:ph type="dt" idx="1"/>
+            <p:ph type="dt" idx="3"/>
           </p:nvPr>
         </p:nvSpPr>
         <p:spPr/>
@@ -1055,7 +1028,7 @@
         <p:spPr>
           <a:xfrm>
             <a:off x="1143000" y="841680"/>
-            <a:ext cx="6857640" cy="1790280"/>
+            <a:ext cx="6857280" cy="1789920"/>
           </a:xfrm>
           <a:prstGeom prst="rect">
             <a:avLst/>
@@ -1070,11 +1043,11 @@
             <a:noAutofit/>
           </a:bodyPr>
           <a:p>
-            <a:endParaRPr b="0" lang="en-US" sz="1800" spc="-1" strike="noStrike">
-              <a:solidFill>
-                <a:srgbClr val="000000"/>
-              </a:solidFill>
-              <a:latin typeface="Calibri"/>
+            <a:pPr algn="ctr">
+              <a:buNone/>
+            </a:pPr>
+            <a:endParaRPr b="0" lang="en-US" sz="4400" spc="-1" strike="noStrike">
+              <a:latin typeface="Arial"/>
             </a:endParaRPr>
           </a:p>
         </p:txBody>
@@ -1107,20 +1080,8 @@
             <a:normAutofit/>
           </a:bodyPr>
           <a:p>
-            <a:pPr>
-              <a:lnSpc>
-                <a:spcPct val="90000"/>
-              </a:lnSpc>
-              <a:spcBef>
-                <a:spcPts val="1417"/>
-              </a:spcBef>
-              <a:buNone/>
-            </a:pPr>
-            <a:endParaRPr b="0" lang="en-US" sz="2100" spc="-1" strike="noStrike">
-              <a:solidFill>
-                <a:srgbClr val="000000"/>
-              </a:solidFill>
-              <a:latin typeface="Calibri"/>
+            <a:endParaRPr b="0" lang="en-US" sz="3200" spc="-1" strike="noStrike">
+              <a:latin typeface="Arial"/>
             </a:endParaRPr>
           </a:p>
         </p:txBody>
@@ -1153,20 +1114,8 @@
             <a:normAutofit/>
           </a:bodyPr>
           <a:p>
-            <a:pPr>
-              <a:lnSpc>
-                <a:spcPct val="90000"/>
-              </a:lnSpc>
-              <a:spcBef>
-                <a:spcPts val="1417"/>
-              </a:spcBef>
-              <a:buNone/>
-            </a:pPr>
-            <a:endParaRPr b="0" lang="en-US" sz="2100" spc="-1" strike="noStrike">
-              <a:solidFill>
-                <a:srgbClr val="000000"/>
-              </a:solidFill>
-              <a:latin typeface="Calibri"/>
+            <a:endParaRPr b="0" lang="en-US" sz="3200" spc="-1" strike="noStrike">
+              <a:latin typeface="Arial"/>
             </a:endParaRPr>
           </a:p>
         </p:txBody>
@@ -1199,20 +1148,8 @@
             <a:normAutofit/>
           </a:bodyPr>
           <a:p>
-            <a:pPr>
-              <a:lnSpc>
-                <a:spcPct val="90000"/>
-              </a:lnSpc>
-              <a:spcBef>
-                <a:spcPts val="1417"/>
-              </a:spcBef>
-              <a:buNone/>
-            </a:pPr>
-            <a:endParaRPr b="0" lang="en-US" sz="2100" spc="-1" strike="noStrike">
-              <a:solidFill>
-                <a:srgbClr val="000000"/>
-              </a:solidFill>
-              <a:latin typeface="Calibri"/>
+            <a:endParaRPr b="0" lang="en-US" sz="3200" spc="-1" strike="noStrike">
+              <a:latin typeface="Arial"/>
             </a:endParaRPr>
           </a:p>
         </p:txBody>
@@ -1245,20 +1182,8 @@
             <a:normAutofit/>
           </a:bodyPr>
           <a:p>
-            <a:pPr>
-              <a:lnSpc>
-                <a:spcPct val="90000"/>
-              </a:lnSpc>
-              <a:spcBef>
-                <a:spcPts val="1417"/>
-              </a:spcBef>
-              <a:buNone/>
-            </a:pPr>
-            <a:endParaRPr b="0" lang="en-US" sz="2100" spc="-1" strike="noStrike">
-              <a:solidFill>
-                <a:srgbClr val="000000"/>
-              </a:solidFill>
-              <a:latin typeface="Calibri"/>
+            <a:endParaRPr b="0" lang="en-US" sz="3200" spc="-1" strike="noStrike">
+              <a:latin typeface="Arial"/>
             </a:endParaRPr>
           </a:p>
         </p:txBody>
@@ -1270,7 +1195,7 @@
             <a:spLocks noGrp="1"/>
           </p:cNvSpPr>
           <p:nvPr>
-            <p:ph type="ftr" idx="2"/>
+            <p:ph type="ftr" idx="1"/>
           </p:nvPr>
         </p:nvSpPr>
         <p:spPr/>
@@ -1290,14 +1215,14 @@
             <a:spLocks noGrp="1"/>
           </p:cNvSpPr>
           <p:nvPr>
-            <p:ph type="sldNum" idx="3"/>
+            <p:ph type="sldNum" idx="2"/>
           </p:nvPr>
         </p:nvSpPr>
         <p:spPr/>
         <p:txBody>
           <a:bodyPr/>
           <a:p>
-            <a:fld id="{ED6E2A5A-97B3-42D0-BF17-BF189746F967}" type="slidenum">
+            <a:fld id="{DBDBBB3D-BB79-4CD9-B57C-676BC653D602}" type="slidenum">
               <a:t>&lt;#&gt;</a:t>
             </a:fld>
           </a:p>
@@ -1310,7 +1235,7 @@
             <a:spLocks noGrp="1"/>
           </p:cNvSpPr>
           <p:nvPr>
-            <p:ph type="dt" idx="1"/>
+            <p:ph type="dt" idx="3"/>
           </p:nvPr>
         </p:nvSpPr>
         <p:spPr/>
@@ -1359,7 +1284,7 @@
         <p:spPr>
           <a:xfrm>
             <a:off x="1143000" y="841680"/>
-            <a:ext cx="6857640" cy="1790280"/>
+            <a:ext cx="6857280" cy="1789920"/>
           </a:xfrm>
           <a:prstGeom prst="rect">
             <a:avLst/>
@@ -1374,11 +1299,11 @@
             <a:noAutofit/>
           </a:bodyPr>
           <a:p>
-            <a:endParaRPr b="0" lang="en-US" sz="1800" spc="-1" strike="noStrike">
-              <a:solidFill>
-                <a:srgbClr val="000000"/>
-              </a:solidFill>
-              <a:latin typeface="Calibri"/>
+            <a:pPr algn="ctr">
+              <a:buNone/>
+            </a:pPr>
+            <a:endParaRPr b="0" lang="en-US" sz="4400" spc="-1" strike="noStrike">
+              <a:latin typeface="Arial"/>
             </a:endParaRPr>
           </a:p>
         </p:txBody>
@@ -1411,20 +1336,8 @@
             <a:normAutofit/>
           </a:bodyPr>
           <a:p>
-            <a:pPr>
-              <a:lnSpc>
-                <a:spcPct val="90000"/>
-              </a:lnSpc>
-              <a:spcBef>
-                <a:spcPts val="1417"/>
-              </a:spcBef>
-              <a:buNone/>
-            </a:pPr>
-            <a:endParaRPr b="0" lang="en-US" sz="2100" spc="-1" strike="noStrike">
-              <a:solidFill>
-                <a:srgbClr val="000000"/>
-              </a:solidFill>
-              <a:latin typeface="Calibri"/>
+            <a:endParaRPr b="0" lang="en-US" sz="3200" spc="-1" strike="noStrike">
+              <a:latin typeface="Arial"/>
             </a:endParaRPr>
           </a:p>
         </p:txBody>
@@ -1457,20 +1370,8 @@
             <a:normAutofit/>
           </a:bodyPr>
           <a:p>
-            <a:pPr>
-              <a:lnSpc>
-                <a:spcPct val="90000"/>
-              </a:lnSpc>
-              <a:spcBef>
-                <a:spcPts val="1417"/>
-              </a:spcBef>
-              <a:buNone/>
-            </a:pPr>
-            <a:endParaRPr b="0" lang="en-US" sz="2100" spc="-1" strike="noStrike">
-              <a:solidFill>
-                <a:srgbClr val="000000"/>
-              </a:solidFill>
-              <a:latin typeface="Calibri"/>
+            <a:endParaRPr b="0" lang="en-US" sz="3200" spc="-1" strike="noStrike">
+              <a:latin typeface="Arial"/>
             </a:endParaRPr>
           </a:p>
         </p:txBody>
@@ -1503,20 +1404,8 @@
             <a:normAutofit/>
           </a:bodyPr>
           <a:p>
-            <a:pPr>
-              <a:lnSpc>
-                <a:spcPct val="90000"/>
-              </a:lnSpc>
-              <a:spcBef>
-                <a:spcPts val="1417"/>
-              </a:spcBef>
-              <a:buNone/>
-            </a:pPr>
-            <a:endParaRPr b="0" lang="en-US" sz="2100" spc="-1" strike="noStrike">
-              <a:solidFill>
-                <a:srgbClr val="000000"/>
-              </a:solidFill>
-              <a:latin typeface="Calibri"/>
+            <a:endParaRPr b="0" lang="en-US" sz="3200" spc="-1" strike="noStrike">
+              <a:latin typeface="Arial"/>
             </a:endParaRPr>
           </a:p>
         </p:txBody>
@@ -1549,20 +1438,8 @@
             <a:normAutofit/>
           </a:bodyPr>
           <a:p>
-            <a:pPr>
-              <a:lnSpc>
-                <a:spcPct val="90000"/>
-              </a:lnSpc>
-              <a:spcBef>
-                <a:spcPts val="1417"/>
-              </a:spcBef>
-              <a:buNone/>
-            </a:pPr>
-            <a:endParaRPr b="0" lang="en-US" sz="2100" spc="-1" strike="noStrike">
-              <a:solidFill>
-                <a:srgbClr val="000000"/>
-              </a:solidFill>
-              <a:latin typeface="Calibri"/>
+            <a:endParaRPr b="0" lang="en-US" sz="3200" spc="-1" strike="noStrike">
+              <a:latin typeface="Arial"/>
             </a:endParaRPr>
           </a:p>
         </p:txBody>
@@ -1595,20 +1472,8 @@
             <a:normAutofit/>
           </a:bodyPr>
           <a:p>
-            <a:pPr>
-              <a:lnSpc>
-                <a:spcPct val="90000"/>
-              </a:lnSpc>
-              <a:spcBef>
-                <a:spcPts val="1417"/>
-              </a:spcBef>
-              <a:buNone/>
-            </a:pPr>
-            <a:endParaRPr b="0" lang="en-US" sz="2100" spc="-1" strike="noStrike">
-              <a:solidFill>
-                <a:srgbClr val="000000"/>
-              </a:solidFill>
-              <a:latin typeface="Calibri"/>
+            <a:endParaRPr b="0" lang="en-US" sz="3200" spc="-1" strike="noStrike">
+              <a:latin typeface="Arial"/>
             </a:endParaRPr>
           </a:p>
         </p:txBody>
@@ -1641,20 +1506,8 @@
             <a:normAutofit/>
           </a:bodyPr>
           <a:p>
-            <a:pPr>
-              <a:lnSpc>
-                <a:spcPct val="90000"/>
-              </a:lnSpc>
-              <a:spcBef>
-                <a:spcPts val="1417"/>
-              </a:spcBef>
-              <a:buNone/>
-            </a:pPr>
-            <a:endParaRPr b="0" lang="en-US" sz="2100" spc="-1" strike="noStrike">
-              <a:solidFill>
-                <a:srgbClr val="000000"/>
-              </a:solidFill>
-              <a:latin typeface="Calibri"/>
+            <a:endParaRPr b="0" lang="en-US" sz="3200" spc="-1" strike="noStrike">
+              <a:latin typeface="Arial"/>
             </a:endParaRPr>
           </a:p>
         </p:txBody>
@@ -1666,7 +1519,7 @@
             <a:spLocks noGrp="1"/>
           </p:cNvSpPr>
           <p:nvPr>
-            <p:ph type="ftr" idx="2"/>
+            <p:ph type="ftr" idx="1"/>
           </p:nvPr>
         </p:nvSpPr>
         <p:spPr/>
@@ -1686,14 +1539,14 @@
             <a:spLocks noGrp="1"/>
           </p:cNvSpPr>
           <p:nvPr>
-            <p:ph type="sldNum" idx="3"/>
+            <p:ph type="sldNum" idx="2"/>
           </p:nvPr>
         </p:nvSpPr>
         <p:spPr/>
         <p:txBody>
           <a:bodyPr/>
           <a:p>
-            <a:fld id="{880939E8-6647-437A-9FDF-95A9B95E2393}" type="slidenum">
+            <a:fld id="{3D403EA3-E3B8-41F9-8533-F2A72C897C38}" type="slidenum">
               <a:t>&lt;#&gt;</a:t>
             </a:fld>
           </a:p>
@@ -1706,7 +1559,7 @@
             <a:spLocks noGrp="1"/>
           </p:cNvSpPr>
           <p:nvPr>
-            <p:ph type="dt" idx="1"/>
+            <p:ph type="dt" idx="3"/>
           </p:nvPr>
         </p:nvSpPr>
         <p:spPr/>
@@ -1755,7 +1608,7 @@
         <p:spPr>
           <a:xfrm>
             <a:off x="1143000" y="841680"/>
-            <a:ext cx="6857640" cy="1790280"/>
+            <a:ext cx="6857280" cy="1789920"/>
           </a:xfrm>
           <a:prstGeom prst="rect">
             <a:avLst/>
@@ -1770,11 +1623,11 @@
             <a:noAutofit/>
           </a:bodyPr>
           <a:p>
-            <a:endParaRPr b="0" lang="en-US" sz="1800" spc="-1" strike="noStrike">
-              <a:solidFill>
-                <a:srgbClr val="000000"/>
-              </a:solidFill>
-              <a:latin typeface="Calibri"/>
+            <a:pPr algn="ctr">
+              <a:buNone/>
+            </a:pPr>
+            <a:endParaRPr b="0" lang="en-US" sz="4400" spc="-1" strike="noStrike">
+              <a:latin typeface="Arial"/>
             </a:endParaRPr>
           </a:p>
         </p:txBody>
@@ -1823,7 +1676,7 @@
             <a:spLocks noGrp="1"/>
           </p:cNvSpPr>
           <p:nvPr>
-            <p:ph type="ftr" idx="2"/>
+            <p:ph type="ftr" idx="1"/>
           </p:nvPr>
         </p:nvSpPr>
         <p:spPr/>
@@ -1843,14 +1696,14 @@
             <a:spLocks noGrp="1"/>
           </p:cNvSpPr>
           <p:nvPr>
-            <p:ph type="sldNum" idx="3"/>
+            <p:ph type="sldNum" idx="2"/>
           </p:nvPr>
         </p:nvSpPr>
         <p:spPr/>
         <p:txBody>
           <a:bodyPr/>
           <a:p>
-            <a:fld id="{A1003197-16FC-4AA9-BEC0-F9D8214D265E}" type="slidenum">
+            <a:fld id="{B24995B3-D3CA-41B4-81A2-2BC4FDEB56AF}" type="slidenum">
               <a:t>&lt;#&gt;</a:t>
             </a:fld>
           </a:p>
@@ -1863,7 +1716,7 @@
             <a:spLocks noGrp="1"/>
           </p:cNvSpPr>
           <p:nvPr>
-            <p:ph type="dt" idx="1"/>
+            <p:ph type="dt" idx="3"/>
           </p:nvPr>
         </p:nvSpPr>
         <p:spPr/>
@@ -1912,7 +1765,7 @@
         <p:spPr>
           <a:xfrm>
             <a:off x="1143000" y="841680"/>
-            <a:ext cx="6857640" cy="1790280"/>
+            <a:ext cx="6857280" cy="1789920"/>
           </a:xfrm>
           <a:prstGeom prst="rect">
             <a:avLst/>
@@ -1927,11 +1780,11 @@
             <a:noAutofit/>
           </a:bodyPr>
           <a:p>
-            <a:endParaRPr b="0" lang="en-US" sz="1800" spc="-1" strike="noStrike">
-              <a:solidFill>
-                <a:srgbClr val="000000"/>
-              </a:solidFill>
-              <a:latin typeface="Calibri"/>
+            <a:pPr algn="ctr">
+              <a:buNone/>
+            </a:pPr>
+            <a:endParaRPr b="0" lang="en-US" sz="4400" spc="-1" strike="noStrike">
+              <a:latin typeface="Arial"/>
             </a:endParaRPr>
           </a:p>
         </p:txBody>
@@ -1964,20 +1817,8 @@
             <a:normAutofit/>
           </a:bodyPr>
           <a:p>
-            <a:pPr>
-              <a:lnSpc>
-                <a:spcPct val="90000"/>
-              </a:lnSpc>
-              <a:spcBef>
-                <a:spcPts val="1417"/>
-              </a:spcBef>
-              <a:buNone/>
-            </a:pPr>
-            <a:endParaRPr b="0" lang="en-US" sz="2100" spc="-1" strike="noStrike">
-              <a:solidFill>
-                <a:srgbClr val="000000"/>
-              </a:solidFill>
-              <a:latin typeface="Calibri"/>
+            <a:endParaRPr b="0" lang="en-US" sz="3200" spc="-1" strike="noStrike">
+              <a:latin typeface="Arial"/>
             </a:endParaRPr>
           </a:p>
         </p:txBody>
@@ -1989,7 +1830,7 @@
             <a:spLocks noGrp="1"/>
           </p:cNvSpPr>
           <p:nvPr>
-            <p:ph type="ftr" idx="2"/>
+            <p:ph type="ftr" idx="1"/>
           </p:nvPr>
         </p:nvSpPr>
         <p:spPr/>
@@ -2009,14 +1850,14 @@
             <a:spLocks noGrp="1"/>
           </p:cNvSpPr>
           <p:nvPr>
-            <p:ph type="sldNum" idx="3"/>
+            <p:ph type="sldNum" idx="2"/>
           </p:nvPr>
         </p:nvSpPr>
         <p:spPr/>
         <p:txBody>
           <a:bodyPr/>
           <a:p>
-            <a:fld id="{CDD4DA0D-18C1-473C-8789-A9AF219CCB80}" type="slidenum">
+            <a:fld id="{B5BA4F9C-C2C8-4CE7-AAAF-392E4CE5EF4D}" type="slidenum">
               <a:t>&lt;#&gt;</a:t>
             </a:fld>
           </a:p>
@@ -2029,7 +1870,7 @@
             <a:spLocks noGrp="1"/>
           </p:cNvSpPr>
           <p:nvPr>
-            <p:ph type="dt" idx="1"/>
+            <p:ph type="dt" idx="3"/>
           </p:nvPr>
         </p:nvSpPr>
         <p:spPr/>
@@ -2078,7 +1919,7 @@
         <p:spPr>
           <a:xfrm>
             <a:off x="1143000" y="841680"/>
-            <a:ext cx="6857640" cy="1790280"/>
+            <a:ext cx="6857280" cy="1789920"/>
           </a:xfrm>
           <a:prstGeom prst="rect">
             <a:avLst/>
@@ -2093,11 +1934,11 @@
             <a:noAutofit/>
           </a:bodyPr>
           <a:p>
-            <a:endParaRPr b="0" lang="en-US" sz="1800" spc="-1" strike="noStrike">
-              <a:solidFill>
-                <a:srgbClr val="000000"/>
-              </a:solidFill>
-              <a:latin typeface="Calibri"/>
+            <a:pPr algn="ctr">
+              <a:buNone/>
+            </a:pPr>
+            <a:endParaRPr b="0" lang="en-US" sz="4400" spc="-1" strike="noStrike">
+              <a:latin typeface="Arial"/>
             </a:endParaRPr>
           </a:p>
         </p:txBody>
@@ -2130,20 +1971,8 @@
             <a:normAutofit/>
           </a:bodyPr>
           <a:p>
-            <a:pPr>
-              <a:lnSpc>
-                <a:spcPct val="90000"/>
-              </a:lnSpc>
-              <a:spcBef>
-                <a:spcPts val="1417"/>
-              </a:spcBef>
-              <a:buNone/>
-            </a:pPr>
-            <a:endParaRPr b="0" lang="en-US" sz="2100" spc="-1" strike="noStrike">
-              <a:solidFill>
-                <a:srgbClr val="000000"/>
-              </a:solidFill>
-              <a:latin typeface="Calibri"/>
+            <a:endParaRPr b="0" lang="en-US" sz="3200" spc="-1" strike="noStrike">
+              <a:latin typeface="Arial"/>
             </a:endParaRPr>
           </a:p>
         </p:txBody>
@@ -2176,20 +2005,8 @@
             <a:normAutofit/>
           </a:bodyPr>
           <a:p>
-            <a:pPr>
-              <a:lnSpc>
-                <a:spcPct val="90000"/>
-              </a:lnSpc>
-              <a:spcBef>
-                <a:spcPts val="1417"/>
-              </a:spcBef>
-              <a:buNone/>
-            </a:pPr>
-            <a:endParaRPr b="0" lang="en-US" sz="2100" spc="-1" strike="noStrike">
-              <a:solidFill>
-                <a:srgbClr val="000000"/>
-              </a:solidFill>
-              <a:latin typeface="Calibri"/>
+            <a:endParaRPr b="0" lang="en-US" sz="3200" spc="-1" strike="noStrike">
+              <a:latin typeface="Arial"/>
             </a:endParaRPr>
           </a:p>
         </p:txBody>
@@ -2201,7 +2018,7 @@
             <a:spLocks noGrp="1"/>
           </p:cNvSpPr>
           <p:nvPr>
-            <p:ph type="ftr" idx="2"/>
+            <p:ph type="ftr" idx="1"/>
           </p:nvPr>
         </p:nvSpPr>
         <p:spPr/>
@@ -2221,14 +2038,14 @@
             <a:spLocks noGrp="1"/>
           </p:cNvSpPr>
           <p:nvPr>
-            <p:ph type="sldNum" idx="3"/>
+            <p:ph type="sldNum" idx="2"/>
           </p:nvPr>
         </p:nvSpPr>
         <p:spPr/>
         <p:txBody>
           <a:bodyPr/>
           <a:p>
-            <a:fld id="{C1820FFE-7CD8-4424-BF04-B909F4CD2F69}" type="slidenum">
+            <a:fld id="{BCFAA850-D07A-40F2-BC8D-85841FB5366C}" type="slidenum">
               <a:t>&lt;#&gt;</a:t>
             </a:fld>
           </a:p>
@@ -2241,7 +2058,7 @@
             <a:spLocks noGrp="1"/>
           </p:cNvSpPr>
           <p:nvPr>
-            <p:ph type="dt" idx="1"/>
+            <p:ph type="dt" idx="3"/>
           </p:nvPr>
         </p:nvSpPr>
         <p:spPr/>
@@ -2290,7 +2107,7 @@
         <p:spPr>
           <a:xfrm>
             <a:off x="1143000" y="841680"/>
-            <a:ext cx="6857640" cy="1790280"/>
+            <a:ext cx="6857280" cy="1789920"/>
           </a:xfrm>
           <a:prstGeom prst="rect">
             <a:avLst/>
@@ -2305,11 +2122,11 @@
             <a:noAutofit/>
           </a:bodyPr>
           <a:p>
-            <a:endParaRPr b="0" lang="en-US" sz="1800" spc="-1" strike="noStrike">
-              <a:solidFill>
-                <a:srgbClr val="000000"/>
-              </a:solidFill>
-              <a:latin typeface="Calibri"/>
+            <a:pPr algn="ctr">
+              <a:buNone/>
+            </a:pPr>
+            <a:endParaRPr b="0" lang="en-US" sz="4400" spc="-1" strike="noStrike">
+              <a:latin typeface="Arial"/>
             </a:endParaRPr>
           </a:p>
         </p:txBody>
@@ -2321,7 +2138,7 @@
             <a:spLocks noGrp="1"/>
           </p:cNvSpPr>
           <p:nvPr>
-            <p:ph type="ftr" idx="2"/>
+            <p:ph type="ftr" idx="1"/>
           </p:nvPr>
         </p:nvSpPr>
         <p:spPr/>
@@ -2341,14 +2158,14 @@
             <a:spLocks noGrp="1"/>
           </p:cNvSpPr>
           <p:nvPr>
-            <p:ph type="sldNum" idx="3"/>
+            <p:ph type="sldNum" idx="2"/>
           </p:nvPr>
         </p:nvSpPr>
         <p:spPr/>
         <p:txBody>
           <a:bodyPr/>
           <a:p>
-            <a:fld id="{038178F6-586B-43E1-A871-E7FE61E86BFC}" type="slidenum">
+            <a:fld id="{ADF607FF-25AF-4708-83C6-D8BD774A2072}" type="slidenum">
               <a:t>&lt;#&gt;</a:t>
             </a:fld>
           </a:p>
@@ -2361,7 +2178,7 @@
             <a:spLocks noGrp="1"/>
           </p:cNvSpPr>
           <p:nvPr>
-            <p:ph type="dt" idx="1"/>
+            <p:ph type="dt" idx="3"/>
           </p:nvPr>
         </p:nvSpPr>
         <p:spPr/>
@@ -2410,7 +2227,7 @@
         <p:spPr>
           <a:xfrm>
             <a:off x="1143000" y="841680"/>
-            <a:ext cx="6857640" cy="8299800"/>
+            <a:ext cx="6857280" cy="8298360"/>
           </a:xfrm>
           <a:prstGeom prst="rect">
             <a:avLst/>
@@ -2441,7 +2258,7 @@
             <a:spLocks noGrp="1"/>
           </p:cNvSpPr>
           <p:nvPr>
-            <p:ph type="ftr" idx="2"/>
+            <p:ph type="ftr" idx="1"/>
           </p:nvPr>
         </p:nvSpPr>
         <p:spPr/>
@@ -2461,14 +2278,14 @@
             <a:spLocks noGrp="1"/>
           </p:cNvSpPr>
           <p:nvPr>
-            <p:ph type="sldNum" idx="3"/>
+            <p:ph type="sldNum" idx="2"/>
           </p:nvPr>
         </p:nvSpPr>
         <p:spPr/>
         <p:txBody>
           <a:bodyPr/>
           <a:p>
-            <a:fld id="{A6BD5788-1531-4916-B770-22D5F4A25618}" type="slidenum">
+            <a:fld id="{60FCB71A-B48F-4305-8A69-637865C74214}" type="slidenum">
               <a:t>&lt;#&gt;</a:t>
             </a:fld>
           </a:p>
@@ -2481,7 +2298,7 @@
             <a:spLocks noGrp="1"/>
           </p:cNvSpPr>
           <p:nvPr>
-            <p:ph type="dt" idx="1"/>
+            <p:ph type="dt" idx="3"/>
           </p:nvPr>
         </p:nvSpPr>
         <p:spPr/>
@@ -2530,7 +2347,7 @@
         <p:spPr>
           <a:xfrm>
             <a:off x="1143000" y="841680"/>
-            <a:ext cx="6857640" cy="1790280"/>
+            <a:ext cx="6857280" cy="1789920"/>
           </a:xfrm>
           <a:prstGeom prst="rect">
             <a:avLst/>
@@ -2545,11 +2362,11 @@
             <a:noAutofit/>
           </a:bodyPr>
           <a:p>
-            <a:endParaRPr b="0" lang="en-US" sz="1800" spc="-1" strike="noStrike">
-              <a:solidFill>
-                <a:srgbClr val="000000"/>
-              </a:solidFill>
-              <a:latin typeface="Calibri"/>
+            <a:pPr algn="ctr">
+              <a:buNone/>
+            </a:pPr>
+            <a:endParaRPr b="0" lang="en-US" sz="4400" spc="-1" strike="noStrike">
+              <a:latin typeface="Arial"/>
             </a:endParaRPr>
           </a:p>
         </p:txBody>
@@ -2582,20 +2399,8 @@
             <a:normAutofit/>
           </a:bodyPr>
           <a:p>
-            <a:pPr>
-              <a:lnSpc>
-                <a:spcPct val="90000"/>
-              </a:lnSpc>
-              <a:spcBef>
-                <a:spcPts val="1417"/>
-              </a:spcBef>
-              <a:buNone/>
-            </a:pPr>
-            <a:endParaRPr b="0" lang="en-US" sz="2100" spc="-1" strike="noStrike">
-              <a:solidFill>
-                <a:srgbClr val="000000"/>
-              </a:solidFill>
-              <a:latin typeface="Calibri"/>
+            <a:endParaRPr b="0" lang="en-US" sz="3200" spc="-1" strike="noStrike">
+              <a:latin typeface="Arial"/>
             </a:endParaRPr>
           </a:p>
         </p:txBody>
@@ -2628,20 +2433,8 @@
             <a:normAutofit/>
           </a:bodyPr>
           <a:p>
-            <a:pPr>
-              <a:lnSpc>
-                <a:spcPct val="90000"/>
-              </a:lnSpc>
-              <a:spcBef>
-                <a:spcPts val="1417"/>
-              </a:spcBef>
-              <a:buNone/>
-            </a:pPr>
-            <a:endParaRPr b="0" lang="en-US" sz="2100" spc="-1" strike="noStrike">
-              <a:solidFill>
-                <a:srgbClr val="000000"/>
-              </a:solidFill>
-              <a:latin typeface="Calibri"/>
+            <a:endParaRPr b="0" lang="en-US" sz="3200" spc="-1" strike="noStrike">
+              <a:latin typeface="Arial"/>
             </a:endParaRPr>
           </a:p>
         </p:txBody>
@@ -2674,20 +2467,8 @@
             <a:normAutofit/>
           </a:bodyPr>
           <a:p>
-            <a:pPr>
-              <a:lnSpc>
-                <a:spcPct val="90000"/>
-              </a:lnSpc>
-              <a:spcBef>
-                <a:spcPts val="1417"/>
-              </a:spcBef>
-              <a:buNone/>
-            </a:pPr>
-            <a:endParaRPr b="0" lang="en-US" sz="2100" spc="-1" strike="noStrike">
-              <a:solidFill>
-                <a:srgbClr val="000000"/>
-              </a:solidFill>
-              <a:latin typeface="Calibri"/>
+            <a:endParaRPr b="0" lang="en-US" sz="3200" spc="-1" strike="noStrike">
+              <a:latin typeface="Arial"/>
             </a:endParaRPr>
           </a:p>
         </p:txBody>
@@ -2699,7 +2480,7 @@
             <a:spLocks noGrp="1"/>
           </p:cNvSpPr>
           <p:nvPr>
-            <p:ph type="ftr" idx="2"/>
+            <p:ph type="ftr" idx="1"/>
           </p:nvPr>
         </p:nvSpPr>
         <p:spPr/>
@@ -2719,14 +2500,14 @@
             <a:spLocks noGrp="1"/>
           </p:cNvSpPr>
           <p:nvPr>
-            <p:ph type="sldNum" idx="3"/>
+            <p:ph type="sldNum" idx="2"/>
           </p:nvPr>
         </p:nvSpPr>
         <p:spPr/>
         <p:txBody>
           <a:bodyPr/>
           <a:p>
-            <a:fld id="{1D7D8CB4-F1EF-4850-9026-57D4600A5C8C}" type="slidenum">
+            <a:fld id="{3A7E18B1-DFFA-4C24-97E6-B0635A7AC9B5}" type="slidenum">
               <a:t>&lt;#&gt;</a:t>
             </a:fld>
           </a:p>
@@ -2739,7 +2520,7 @@
             <a:spLocks noGrp="1"/>
           </p:cNvSpPr>
           <p:nvPr>
-            <p:ph type="dt" idx="1"/>
+            <p:ph type="dt" idx="3"/>
           </p:nvPr>
         </p:nvSpPr>
         <p:spPr/>
@@ -2788,7 +2569,7 @@
         <p:spPr>
           <a:xfrm>
             <a:off x="1143000" y="841680"/>
-            <a:ext cx="6857640" cy="1790280"/>
+            <a:ext cx="6857280" cy="1789920"/>
           </a:xfrm>
           <a:prstGeom prst="rect">
             <a:avLst/>
@@ -2803,11 +2584,11 @@
             <a:noAutofit/>
           </a:bodyPr>
           <a:p>
-            <a:endParaRPr b="0" lang="en-US" sz="1800" spc="-1" strike="noStrike">
-              <a:solidFill>
-                <a:srgbClr val="000000"/>
-              </a:solidFill>
-              <a:latin typeface="Calibri"/>
+            <a:pPr algn="ctr">
+              <a:buNone/>
+            </a:pPr>
+            <a:endParaRPr b="0" lang="en-US" sz="4400" spc="-1" strike="noStrike">
+              <a:latin typeface="Arial"/>
             </a:endParaRPr>
           </a:p>
         </p:txBody>
@@ -2840,20 +2621,8 @@
             <a:normAutofit/>
           </a:bodyPr>
           <a:p>
-            <a:pPr>
-              <a:lnSpc>
-                <a:spcPct val="90000"/>
-              </a:lnSpc>
-              <a:spcBef>
-                <a:spcPts val="1417"/>
-              </a:spcBef>
-              <a:buNone/>
-            </a:pPr>
-            <a:endParaRPr b="0" lang="en-US" sz="2100" spc="-1" strike="noStrike">
-              <a:solidFill>
-                <a:srgbClr val="000000"/>
-              </a:solidFill>
-              <a:latin typeface="Calibri"/>
+            <a:endParaRPr b="0" lang="en-US" sz="3200" spc="-1" strike="noStrike">
+              <a:latin typeface="Arial"/>
             </a:endParaRPr>
           </a:p>
         </p:txBody>
@@ -2886,20 +2655,8 @@
             <a:normAutofit/>
           </a:bodyPr>
           <a:p>
-            <a:pPr>
-              <a:lnSpc>
-                <a:spcPct val="90000"/>
-              </a:lnSpc>
-              <a:spcBef>
-                <a:spcPts val="1417"/>
-              </a:spcBef>
-              <a:buNone/>
-            </a:pPr>
-            <a:endParaRPr b="0" lang="en-US" sz="2100" spc="-1" strike="noStrike">
-              <a:solidFill>
-                <a:srgbClr val="000000"/>
-              </a:solidFill>
-              <a:latin typeface="Calibri"/>
+            <a:endParaRPr b="0" lang="en-US" sz="3200" spc="-1" strike="noStrike">
+              <a:latin typeface="Arial"/>
             </a:endParaRPr>
           </a:p>
         </p:txBody>
@@ -2932,20 +2689,8 @@
             <a:normAutofit/>
           </a:bodyPr>
           <a:p>
-            <a:pPr>
-              <a:lnSpc>
-                <a:spcPct val="90000"/>
-              </a:lnSpc>
-              <a:spcBef>
-                <a:spcPts val="1417"/>
-              </a:spcBef>
-              <a:buNone/>
-            </a:pPr>
-            <a:endParaRPr b="0" lang="en-US" sz="2100" spc="-1" strike="noStrike">
-              <a:solidFill>
-                <a:srgbClr val="000000"/>
-              </a:solidFill>
-              <a:latin typeface="Calibri"/>
+            <a:endParaRPr b="0" lang="en-US" sz="3200" spc="-1" strike="noStrike">
+              <a:latin typeface="Arial"/>
             </a:endParaRPr>
           </a:p>
         </p:txBody>
@@ -2957,7 +2702,7 @@
             <a:spLocks noGrp="1"/>
           </p:cNvSpPr>
           <p:nvPr>
-            <p:ph type="ftr" idx="2"/>
+            <p:ph type="ftr" idx="1"/>
           </p:nvPr>
         </p:nvSpPr>
         <p:spPr/>
@@ -2977,14 +2722,14 @@
             <a:spLocks noGrp="1"/>
           </p:cNvSpPr>
           <p:nvPr>
-            <p:ph type="sldNum" idx="3"/>
+            <p:ph type="sldNum" idx="2"/>
           </p:nvPr>
         </p:nvSpPr>
         <p:spPr/>
         <p:txBody>
           <a:bodyPr/>
           <a:p>
-            <a:fld id="{3621E360-4F5D-478D-B521-61FA286301FF}" type="slidenum">
+            <a:fld id="{69B46C95-30C0-475C-9178-1E629C7EA3EF}" type="slidenum">
               <a:t>&lt;#&gt;</a:t>
             </a:fld>
           </a:p>
@@ -2997,7 +2742,7 @@
             <a:spLocks noGrp="1"/>
           </p:cNvSpPr>
           <p:nvPr>
-            <p:ph type="dt" idx="1"/>
+            <p:ph type="dt" idx="3"/>
           </p:nvPr>
         </p:nvSpPr>
         <p:spPr/>
@@ -3046,7 +2791,7 @@
         <p:spPr>
           <a:xfrm>
             <a:off x="1143000" y="841680"/>
-            <a:ext cx="6857640" cy="1790280"/>
+            <a:ext cx="6857280" cy="1789920"/>
           </a:xfrm>
           <a:prstGeom prst="rect">
             <a:avLst/>
@@ -3061,11 +2806,11 @@
             <a:noAutofit/>
           </a:bodyPr>
           <a:p>
-            <a:endParaRPr b="0" lang="en-US" sz="1800" spc="-1" strike="noStrike">
-              <a:solidFill>
-                <a:srgbClr val="000000"/>
-              </a:solidFill>
-              <a:latin typeface="Calibri"/>
+            <a:pPr algn="ctr">
+              <a:buNone/>
+            </a:pPr>
+            <a:endParaRPr b="0" lang="en-US" sz="4400" spc="-1" strike="noStrike">
+              <a:latin typeface="Arial"/>
             </a:endParaRPr>
           </a:p>
         </p:txBody>
@@ -3098,20 +2843,8 @@
             <a:normAutofit/>
           </a:bodyPr>
           <a:p>
-            <a:pPr>
-              <a:lnSpc>
-                <a:spcPct val="90000"/>
-              </a:lnSpc>
-              <a:spcBef>
-                <a:spcPts val="1417"/>
-              </a:spcBef>
-              <a:buNone/>
-            </a:pPr>
-            <a:endParaRPr b="0" lang="en-US" sz="2100" spc="-1" strike="noStrike">
-              <a:solidFill>
-                <a:srgbClr val="000000"/>
-              </a:solidFill>
-              <a:latin typeface="Calibri"/>
+            <a:endParaRPr b="0" lang="en-US" sz="3200" spc="-1" strike="noStrike">
+              <a:latin typeface="Arial"/>
             </a:endParaRPr>
           </a:p>
         </p:txBody>
@@ -3144,20 +2877,8 @@
             <a:normAutofit/>
           </a:bodyPr>
           <a:p>
-            <a:pPr>
-              <a:lnSpc>
-                <a:spcPct val="90000"/>
-              </a:lnSpc>
-              <a:spcBef>
-                <a:spcPts val="1417"/>
-              </a:spcBef>
-              <a:buNone/>
-            </a:pPr>
-            <a:endParaRPr b="0" lang="en-US" sz="2100" spc="-1" strike="noStrike">
-              <a:solidFill>
-                <a:srgbClr val="000000"/>
-              </a:solidFill>
-              <a:latin typeface="Calibri"/>
+            <a:endParaRPr b="0" lang="en-US" sz="3200" spc="-1" strike="noStrike">
+              <a:latin typeface="Arial"/>
             </a:endParaRPr>
           </a:p>
         </p:txBody>
@@ -3190,20 +2911,8 @@
             <a:normAutofit/>
           </a:bodyPr>
           <a:p>
-            <a:pPr>
-              <a:lnSpc>
-                <a:spcPct val="90000"/>
-              </a:lnSpc>
-              <a:spcBef>
-                <a:spcPts val="1417"/>
-              </a:spcBef>
-              <a:buNone/>
-            </a:pPr>
-            <a:endParaRPr b="0" lang="en-US" sz="2100" spc="-1" strike="noStrike">
-              <a:solidFill>
-                <a:srgbClr val="000000"/>
-              </a:solidFill>
-              <a:latin typeface="Calibri"/>
+            <a:endParaRPr b="0" lang="en-US" sz="3200" spc="-1" strike="noStrike">
+              <a:latin typeface="Arial"/>
             </a:endParaRPr>
           </a:p>
         </p:txBody>
@@ -3215,7 +2924,7 @@
             <a:spLocks noGrp="1"/>
           </p:cNvSpPr>
           <p:nvPr>
-            <p:ph type="ftr" idx="2"/>
+            <p:ph type="ftr" idx="1"/>
           </p:nvPr>
         </p:nvSpPr>
         <p:spPr/>
@@ -3235,14 +2944,14 @@
             <a:spLocks noGrp="1"/>
           </p:cNvSpPr>
           <p:nvPr>
-            <p:ph type="sldNum" idx="3"/>
+            <p:ph type="sldNum" idx="2"/>
           </p:nvPr>
         </p:nvSpPr>
         <p:spPr/>
         <p:txBody>
           <a:bodyPr/>
           <a:p>
-            <a:fld id="{009B8F28-99AA-4130-A4C7-4D49E12159EB}" type="slidenum">
+            <a:fld id="{17B345AA-B326-4C2A-8F1A-F927C04A3650}" type="slidenum">
               <a:t>&lt;#&gt;</a:t>
             </a:fld>
           </a:p>
@@ -3255,7 +2964,7 @@
             <a:spLocks noGrp="1"/>
           </p:cNvSpPr>
           <p:nvPr>
-            <p:ph type="dt" idx="1"/>
+            <p:ph type="dt" idx="3"/>
           </p:nvPr>
         </p:nvSpPr>
         <p:spPr/>
@@ -3311,41 +3020,29 @@
         <p:spPr>
           <a:xfrm>
             <a:off x="1143000" y="841680"/>
-            <a:ext cx="6857640" cy="1790280"/>
-          </a:xfrm>
-          <a:prstGeom prst="rect">
-            <a:avLst/>
-          </a:prstGeom>
-          <a:noFill/>
-          <a:ln w="0">
-            <a:noFill/>
-          </a:ln>
-        </p:spPr>
-        <p:txBody>
-          <a:bodyPr anchor="b">
-            <a:noAutofit/>
-          </a:bodyPr>
-          <a:p>
-            <a:pPr algn="ctr">
-              <a:lnSpc>
-                <a:spcPct val="90000"/>
-              </a:lnSpc>
-              <a:buNone/>
-            </a:pPr>
-            <a:r>
-              <a:rPr b="0" lang="ru-RU" sz="4500" spc="-1" strike="noStrike">
-                <a:solidFill>
-                  <a:srgbClr val="000000"/>
-                </a:solidFill>
-                <a:latin typeface="Calibri Light"/>
-              </a:rPr>
-              <a:t>Образец заголовка</a:t>
-            </a:r>
-            <a:endParaRPr b="0" lang="en-US" sz="4500" spc="-1" strike="noStrike">
-              <a:solidFill>
-                <a:srgbClr val="000000"/>
-              </a:solidFill>
-              <a:latin typeface="Calibri"/>
+            <a:ext cx="6857280" cy="1789920"/>
+          </a:xfrm>
+          <a:prstGeom prst="rect">
+            <a:avLst/>
+          </a:prstGeom>
+          <a:noFill/>
+          <a:ln w="0">
+            <a:noFill/>
+          </a:ln>
+        </p:spPr>
+        <p:txBody>
+          <a:bodyPr lIns="0" rIns="0" tIns="0" bIns="0" anchor="ctr">
+            <a:noAutofit/>
+          </a:bodyPr>
+          <a:p>
+            <a:r>
+              <a:rPr b="0" lang="en-US" sz="1800" spc="-1" strike="noStrike">
+                <a:latin typeface="Arial"/>
+              </a:rPr>
+              <a:t>Click to edit the title text format</a:t>
+            </a:r>
+            <a:endParaRPr b="0" lang="en-US" sz="1800" spc="-1" strike="noStrike">
+              <a:latin typeface="Arial"/>
             </a:endParaRPr>
           </a:p>
         </p:txBody>
@@ -3357,57 +3054,51 @@
             <a:spLocks noGrp="1"/>
           </p:cNvSpPr>
           <p:nvPr>
-            <p:ph type="dt" idx="1"/>
+            <p:ph type="ftr" idx="1"/>
           </p:nvPr>
         </p:nvSpPr>
         <p:spPr>
           <a:xfrm>
-            <a:off x="628560" y="4767120"/>
-            <a:ext cx="2057040" cy="273600"/>
-          </a:xfrm>
-          <a:prstGeom prst="rect">
-            <a:avLst/>
-          </a:prstGeom>
-          <a:noFill/>
-          <a:ln w="0">
-            <a:noFill/>
-          </a:ln>
-        </p:spPr>
-        <p:txBody>
-          <a:bodyPr anchor="ctr">
+            <a:off x="3029040" y="4767120"/>
+            <a:ext cx="3085560" cy="273240"/>
+          </a:xfrm>
+          <a:prstGeom prst="rect">
+            <a:avLst/>
+          </a:prstGeom>
+          <a:noFill/>
+          <a:ln w="0">
+            <a:noFill/>
+          </a:ln>
+        </p:spPr>
+        <p:txBody>
+          <a:bodyPr lIns="90000" rIns="90000" tIns="45000" bIns="45000" anchor="ctr">
             <a:noAutofit/>
           </a:bodyPr>
           <a:lstStyle>
-            <a:lvl1pPr>
+            <a:lvl1pPr algn="ctr">
               <a:lnSpc>
                 <a:spcPct val="100000"/>
               </a:lnSpc>
               <a:buNone/>
-              <a:defRPr b="0" lang="en-US" sz="900" spc="-1" strike="noStrike">
-                <a:solidFill>
-                  <a:srgbClr val="8b8b8b"/>
-                </a:solidFill>
-                <a:latin typeface="Calibri"/>
+              <a:defRPr b="0" lang="en-US" sz="1400" spc="-1" strike="noStrike">
+                <a:latin typeface="Times New Roman"/>
               </a:defRPr>
             </a:lvl1pPr>
           </a:lstStyle>
           <a:p>
-            <a:pPr>
+            <a:pPr algn="ctr">
               <a:lnSpc>
                 <a:spcPct val="100000"/>
               </a:lnSpc>
               <a:buNone/>
             </a:pPr>
             <a:r>
-              <a:rPr b="0" lang="en-US" sz="900" spc="-1" strike="noStrike">
-                <a:solidFill>
-                  <a:srgbClr val="8b8b8b"/>
-                </a:solidFill>
-                <a:latin typeface="Calibri"/>
-              </a:rPr>
-              <a:t>&lt;date/time&gt;</a:t>
-            </a:r>
-            <a:endParaRPr b="0" lang="en-US" sz="900" spc="-1" strike="noStrike">
+              <a:rPr b="0" lang="en-US" sz="1400" spc="-1" strike="noStrike">
+                <a:latin typeface="Times New Roman"/>
+              </a:rPr>
+              <a:t>&lt;footer&gt;</a:t>
+            </a:r>
+            <a:endParaRPr b="0" lang="en-US" sz="1400" spc="-1" strike="noStrike">
               <a:latin typeface="Times New Roman"/>
             </a:endParaRPr>
           </a:p>
@@ -3420,108 +3111,104 @@
             <a:spLocks noGrp="1"/>
           </p:cNvSpPr>
           <p:nvPr>
-            <p:ph type="ftr" idx="2"/>
+            <p:ph type="sldNum" idx="2"/>
           </p:nvPr>
         </p:nvSpPr>
         <p:spPr>
           <a:xfrm>
-            <a:off x="3029040" y="4767120"/>
-            <a:ext cx="3085920" cy="273600"/>
-          </a:xfrm>
-          <a:prstGeom prst="rect">
-            <a:avLst/>
-          </a:prstGeom>
-          <a:noFill/>
-          <a:ln w="0">
-            <a:noFill/>
-          </a:ln>
-        </p:spPr>
-        <p:txBody>
-          <a:bodyPr anchor="ctr">
+            <a:off x="6458040" y="4767120"/>
+            <a:ext cx="2056680" cy="273240"/>
+          </a:xfrm>
+          <a:prstGeom prst="rect">
+            <a:avLst/>
+          </a:prstGeom>
+          <a:noFill/>
+          <a:ln w="0">
+            <a:noFill/>
+          </a:ln>
+        </p:spPr>
+        <p:txBody>
+          <a:bodyPr lIns="90000" rIns="90000" tIns="45000" bIns="45000" anchor="ctr">
             <a:noAutofit/>
           </a:bodyPr>
           <a:lstStyle>
-            <a:lvl1pPr algn="ctr">
-              <a:buNone/>
+            <a:lvl1pPr algn="r">
+              <a:lnSpc>
+                <a:spcPct val="100000"/>
+              </a:lnSpc>
+              <a:buNone/>
+              <a:defRPr b="0" lang="en-US" sz="900" spc="-1" strike="noStrike">
+                <a:solidFill>
+                  <a:srgbClr val="8b8b8b"/>
+                </a:solidFill>
+                <a:latin typeface="Calibri"/>
+              </a:defRPr>
+            </a:lvl1pPr>
+          </a:lstStyle>
+          <a:p>
+            <a:pPr algn="r">
+              <a:lnSpc>
+                <a:spcPct val="100000"/>
+              </a:lnSpc>
+              <a:buNone/>
+            </a:pPr>
+            <a:fld id="{4C2E32EB-3FCE-45A3-85F8-702BCF0C0863}" type="slidenum">
+              <a:rPr b="0" lang="en-US" sz="900" spc="-1" strike="noStrike">
+                <a:solidFill>
+                  <a:srgbClr val="8b8b8b"/>
+                </a:solidFill>
+                <a:latin typeface="Calibri"/>
+              </a:rPr>
+              <a:t>&lt;number&gt;</a:t>
+            </a:fld>
+            <a:endParaRPr b="0" lang="en-US" sz="900" spc="-1" strike="noStrike">
+              <a:latin typeface="Times New Roman"/>
+            </a:endParaRPr>
+          </a:p>
+        </p:txBody>
+      </p:sp>
+      <p:sp>
+        <p:nvSpPr>
+          <p:cNvPr id="3" name="PlaceHolder 4"/>
+          <p:cNvSpPr>
+            <a:spLocks noGrp="1"/>
+          </p:cNvSpPr>
+          <p:nvPr>
+            <p:ph type="dt" idx="3"/>
+          </p:nvPr>
+        </p:nvSpPr>
+        <p:spPr>
+          <a:xfrm>
+            <a:off x="628560" y="4767120"/>
+            <a:ext cx="2056680" cy="273240"/>
+          </a:xfrm>
+          <a:prstGeom prst="rect">
+            <a:avLst/>
+          </a:prstGeom>
+          <a:noFill/>
+          <a:ln w="0">
+            <a:noFill/>
+          </a:ln>
+        </p:spPr>
+        <p:txBody>
+          <a:bodyPr lIns="90000" rIns="90000" tIns="45000" bIns="45000" anchor="ctr">
+            <a:noAutofit/>
+          </a:bodyPr>
+          <a:lstStyle>
+            <a:lvl1pPr>
               <a:defRPr b="0" lang="en-US" sz="1400" spc="-1" strike="noStrike">
                 <a:latin typeface="Times New Roman"/>
               </a:defRPr>
             </a:lvl1pPr>
           </a:lstStyle>
           <a:p>
-            <a:pPr algn="ctr">
-              <a:buNone/>
-            </a:pPr>
             <a:r>
               <a:rPr b="0" lang="en-US" sz="1400" spc="-1" strike="noStrike">
                 <a:latin typeface="Times New Roman"/>
               </a:rPr>
-              <a:t>&lt;footer&gt;</a:t>
+              <a:t>&lt;date/time&gt;</a:t>
             </a:r>
             <a:endParaRPr b="0" lang="en-US" sz="1400" spc="-1" strike="noStrike">
-              <a:latin typeface="Times New Roman"/>
-            </a:endParaRPr>
-          </a:p>
-        </p:txBody>
-      </p:sp>
-      <p:sp>
-        <p:nvSpPr>
-          <p:cNvPr id="3" name="PlaceHolder 4"/>
-          <p:cNvSpPr>
-            <a:spLocks noGrp="1"/>
-          </p:cNvSpPr>
-          <p:nvPr>
-            <p:ph type="sldNum" idx="3"/>
-          </p:nvPr>
-        </p:nvSpPr>
-        <p:spPr>
-          <a:xfrm>
-            <a:off x="6458040" y="4767120"/>
-            <a:ext cx="2057040" cy="273600"/>
-          </a:xfrm>
-          <a:prstGeom prst="rect">
-            <a:avLst/>
-          </a:prstGeom>
-          <a:noFill/>
-          <a:ln w="0">
-            <a:noFill/>
-          </a:ln>
-        </p:spPr>
-        <p:txBody>
-          <a:bodyPr anchor="ctr">
-            <a:noAutofit/>
-          </a:bodyPr>
-          <a:lstStyle>
-            <a:lvl1pPr algn="r">
-              <a:lnSpc>
-                <a:spcPct val="100000"/>
-              </a:lnSpc>
-              <a:buNone/>
-              <a:defRPr b="0" lang="en-US" sz="900" spc="-1" strike="noStrike">
-                <a:solidFill>
-                  <a:srgbClr val="8b8b8b"/>
-                </a:solidFill>
-                <a:latin typeface="Calibri"/>
-              </a:defRPr>
-            </a:lvl1pPr>
-          </a:lstStyle>
-          <a:p>
-            <a:pPr algn="r">
-              <a:lnSpc>
-                <a:spcPct val="100000"/>
-              </a:lnSpc>
-              <a:buNone/>
-            </a:pPr>
-            <a:fld id="{8975EFE0-4D69-4C77-941B-E84D4CC79A0C}" type="slidenum">
-              <a:rPr b="0" lang="en-US" sz="900" spc="-1" strike="noStrike">
-                <a:solidFill>
-                  <a:srgbClr val="8b8b8b"/>
-                </a:solidFill>
-                <a:latin typeface="Calibri"/>
-              </a:rPr>
-              <a:t>&lt;number&gt;</a:t>
-            </a:fld>
-            <a:endParaRPr b="0" lang="en-US" sz="900" spc="-1" strike="noStrike">
               <a:latin typeface="Times New Roman"/>
             </a:endParaRPr>
           </a:p>
@@ -3556,9 +3243,6 @@
           </a:bodyPr>
           <a:p>
             <a:pPr marL="432000" indent="-324000">
-              <a:lnSpc>
-                <a:spcPct val="90000"/>
-              </a:lnSpc>
               <a:spcBef>
                 <a:spcPts val="1417"/>
               </a:spcBef>
@@ -3570,26 +3254,17 @@
               <a:buChar char=""/>
             </a:pPr>
             <a:r>
-              <a:rPr b="0" lang="en-US" sz="2100" spc="-1" strike="noStrike">
-                <a:solidFill>
-                  <a:srgbClr val="000000"/>
-                </a:solidFill>
-                <a:latin typeface="Calibri"/>
+              <a:rPr b="0" lang="en-US" sz="3200" spc="-1" strike="noStrike">
+                <a:latin typeface="Arial"/>
               </a:rPr>
               <a:t>Click to edit the outline text format</a:t>
             </a:r>
-            <a:endParaRPr b="0" lang="en-US" sz="2100" spc="-1" strike="noStrike">
-              <a:solidFill>
-                <a:srgbClr val="000000"/>
-              </a:solidFill>
-              <a:latin typeface="Calibri"/>
+            <a:endParaRPr b="0" lang="en-US" sz="3200" spc="-1" strike="noStrike">
+              <a:latin typeface="Arial"/>
             </a:endParaRPr>
           </a:p>
           <a:p>
             <a:pPr lvl="1" marL="864000" indent="-324000">
-              <a:lnSpc>
-                <a:spcPct val="90000"/>
-              </a:lnSpc>
               <a:spcBef>
                 <a:spcPts val="1134"/>
               </a:spcBef>
@@ -3601,26 +3276,17 @@
               <a:buChar char=""/>
             </a:pPr>
             <a:r>
-              <a:rPr b="0" lang="en-US" sz="1500" spc="-1" strike="noStrike">
-                <a:solidFill>
-                  <a:srgbClr val="000000"/>
-                </a:solidFill>
-                <a:latin typeface="Calibri"/>
+              <a:rPr b="0" lang="en-US" sz="2800" spc="-1" strike="noStrike">
+                <a:latin typeface="Arial"/>
               </a:rPr>
               <a:t>Second Outline Level</a:t>
             </a:r>
-            <a:endParaRPr b="0" lang="en-US" sz="1500" spc="-1" strike="noStrike">
-              <a:solidFill>
-                <a:srgbClr val="000000"/>
-              </a:solidFill>
-              <a:latin typeface="Calibri"/>
+            <a:endParaRPr b="0" lang="en-US" sz="2800" spc="-1" strike="noStrike">
+              <a:latin typeface="Arial"/>
             </a:endParaRPr>
           </a:p>
           <a:p>
             <a:pPr lvl="2" marL="1296000" indent="-288000">
-              <a:lnSpc>
-                <a:spcPct val="90000"/>
-              </a:lnSpc>
               <a:spcBef>
                 <a:spcPts val="850"/>
               </a:spcBef>
@@ -3632,26 +3298,17 @@
               <a:buChar char=""/>
             </a:pPr>
             <a:r>
-              <a:rPr b="0" lang="en-US" sz="1350" spc="-1" strike="noStrike">
-                <a:solidFill>
-                  <a:srgbClr val="000000"/>
-                </a:solidFill>
-                <a:latin typeface="Calibri"/>
+              <a:rPr b="0" lang="en-US" sz="2400" spc="-1" strike="noStrike">
+                <a:latin typeface="Arial"/>
               </a:rPr>
               <a:t>Third Outline Level</a:t>
             </a:r>
-            <a:endParaRPr b="0" lang="en-US" sz="1350" spc="-1" strike="noStrike">
-              <a:solidFill>
-                <a:srgbClr val="000000"/>
-              </a:solidFill>
-              <a:latin typeface="Calibri"/>
+            <a:endParaRPr b="0" lang="en-US" sz="2400" spc="-1" strike="noStrike">
+              <a:latin typeface="Arial"/>
             </a:endParaRPr>
           </a:p>
           <a:p>
             <a:pPr lvl="3" marL="1728000" indent="-216000">
-              <a:lnSpc>
-                <a:spcPct val="90000"/>
-              </a:lnSpc>
               <a:spcBef>
                 <a:spcPts val="567"/>
               </a:spcBef>
@@ -3663,26 +3320,17 @@
               <a:buChar char=""/>
             </a:pPr>
             <a:r>
-              <a:rPr b="0" lang="en-US" sz="1350" spc="-1" strike="noStrike">
-                <a:solidFill>
-                  <a:srgbClr val="000000"/>
-                </a:solidFill>
-                <a:latin typeface="Calibri"/>
+              <a:rPr b="0" lang="en-US" sz="2000" spc="-1" strike="noStrike">
+                <a:latin typeface="Arial"/>
               </a:rPr>
               <a:t>Fourth Outline Level</a:t>
             </a:r>
-            <a:endParaRPr b="0" lang="en-US" sz="1350" spc="-1" strike="noStrike">
-              <a:solidFill>
-                <a:srgbClr val="000000"/>
-              </a:solidFill>
-              <a:latin typeface="Calibri"/>
+            <a:endParaRPr b="0" lang="en-US" sz="2000" spc="-1" strike="noStrike">
+              <a:latin typeface="Arial"/>
             </a:endParaRPr>
           </a:p>
           <a:p>
             <a:pPr lvl="4" marL="2160000" indent="-216000">
-              <a:lnSpc>
-                <a:spcPct val="90000"/>
-              </a:lnSpc>
               <a:spcBef>
                 <a:spcPts val="283"/>
               </a:spcBef>
@@ -3695,25 +3343,16 @@
             </a:pPr>
             <a:r>
               <a:rPr b="0" lang="en-US" sz="2000" spc="-1" strike="noStrike">
-                <a:solidFill>
-                  <a:srgbClr val="000000"/>
-                </a:solidFill>
-                <a:latin typeface="Calibri"/>
+                <a:latin typeface="Arial"/>
               </a:rPr>
               <a:t>Fifth Outline Level</a:t>
             </a:r>
             <a:endParaRPr b="0" lang="en-US" sz="2000" spc="-1" strike="noStrike">
-              <a:solidFill>
-                <a:srgbClr val="000000"/>
-              </a:solidFill>
-              <a:latin typeface="Calibri"/>
+              <a:latin typeface="Arial"/>
             </a:endParaRPr>
           </a:p>
           <a:p>
             <a:pPr lvl="5" marL="2592000" indent="-216000">
-              <a:lnSpc>
-                <a:spcPct val="90000"/>
-              </a:lnSpc>
               <a:spcBef>
                 <a:spcPts val="283"/>
               </a:spcBef>
@@ -3726,25 +3365,16 @@
             </a:pPr>
             <a:r>
               <a:rPr b="0" lang="en-US" sz="2000" spc="-1" strike="noStrike">
-                <a:solidFill>
-                  <a:srgbClr val="000000"/>
-                </a:solidFill>
-                <a:latin typeface="Calibri"/>
+                <a:latin typeface="Arial"/>
               </a:rPr>
               <a:t>Sixth Outline Level</a:t>
             </a:r>
             <a:endParaRPr b="0" lang="en-US" sz="2000" spc="-1" strike="noStrike">
-              <a:solidFill>
-                <a:srgbClr val="000000"/>
-              </a:solidFill>
-              <a:latin typeface="Calibri"/>
+              <a:latin typeface="Arial"/>
             </a:endParaRPr>
           </a:p>
           <a:p>
             <a:pPr lvl="6" marL="3024000" indent="-216000">
-              <a:lnSpc>
-                <a:spcPct val="90000"/>
-              </a:lnSpc>
               <a:spcBef>
                 <a:spcPts val="283"/>
               </a:spcBef>
@@ -3757,18 +3387,12 @@
             </a:pPr>
             <a:r>
               <a:rPr b="0" lang="en-US" sz="2000" spc="-1" strike="noStrike">
-                <a:solidFill>
-                  <a:srgbClr val="000000"/>
-                </a:solidFill>
-                <a:latin typeface="Calibri"/>
+                <a:latin typeface="Arial"/>
               </a:rPr>
               <a:t>Seventh Outline Level</a:t>
             </a:r>
             <a:endParaRPr b="0" lang="en-US" sz="2000" spc="-1" strike="noStrike">
-              <a:solidFill>
-                <a:srgbClr val="000000"/>
-              </a:solidFill>
-              <a:latin typeface="Calibri"/>
+              <a:latin typeface="Arial"/>
             </a:endParaRPr>
           </a:p>
         </p:txBody>
@@ -3826,7 +3450,7 @@
         <p:spPr>
           <a:xfrm>
             <a:off x="186840" y="185400"/>
-            <a:ext cx="8770320" cy="4758120"/>
+            <a:ext cx="8769960" cy="4757760"/>
           </a:xfrm>
           <a:prstGeom prst="roundRect">
             <a:avLst>
@@ -3864,7 +3488,7 @@
         <p:spPr>
           <a:xfrm>
             <a:off x="460080" y="658080"/>
-            <a:ext cx="8469000" cy="3306960"/>
+            <a:ext cx="8468640" cy="3306600"/>
           </a:xfrm>
           <a:prstGeom prst="rect">
             <a:avLst/>
@@ -3916,7 +3540,7 @@
         <p:spPr>
           <a:xfrm>
             <a:off x="460080" y="4595760"/>
-            <a:ext cx="2999160" cy="269640"/>
+            <a:ext cx="2998800" cy="269280"/>
           </a:xfrm>
           <a:prstGeom prst="rect">
             <a:avLst/>
@@ -3949,6 +3573,7 @@
                   <a:srgbClr val="f2f2f2"/>
                 </a:solidFill>
                 <a:latin typeface="Arial"/>
+                <a:ea typeface="DejaVu Sans"/>
               </a:rPr>
               <a:t>Презентация создана в </a:t>
             </a:r>
@@ -3958,6 +3583,7 @@
                   <a:srgbClr val="f2f2f2"/>
                 </a:solidFill>
                 <a:latin typeface="Arial"/>
+                <a:ea typeface="DejaVu Sans"/>
               </a:rPr>
               <a:t>Fibonacci</a:t>
             </a:r>
@@ -3980,7 +3606,7 @@
         <p:spPr>
           <a:xfrm>
             <a:off x="2423160" y="4596480"/>
-            <a:ext cx="291240" cy="291240"/>
+            <a:ext cx="290880" cy="290880"/>
           </a:xfrm>
           <a:prstGeom prst="rect">
             <a:avLst/>
@@ -3990,57 +3616,6 @@
           </a:ln>
         </p:spPr>
       </p:pic>
-      <p:sp>
-        <p:nvSpPr>
-          <p:cNvPr id="51" name="Прямоугольник 5"/>
-          <p:cNvSpPr/>
-          <p:nvPr/>
-        </p:nvSpPr>
-        <p:spPr>
-          <a:xfrm>
-            <a:off x="460080" y="358920"/>
-            <a:ext cx="2999160" cy="269640"/>
-          </a:xfrm>
-          <a:prstGeom prst="rect">
-            <a:avLst/>
-          </a:prstGeom>
-          <a:noFill/>
-          <a:ln w="0">
-            <a:noFill/>
-          </a:ln>
-        </p:spPr>
-        <p:style>
-          <a:lnRef idx="0"/>
-          <a:fillRef idx="0"/>
-          <a:effectRef idx="0"/>
-          <a:fontRef idx="minor"/>
-        </p:style>
-        <p:txBody>
-          <a:bodyPr lIns="90000" rIns="90000" tIns="45000" bIns="45000" anchor="t">
-            <a:noAutofit/>
-          </a:bodyPr>
-          <a:p>
-            <a:pPr>
-              <a:lnSpc>
-                <a:spcPts val="1650"/>
-              </a:lnSpc>
-              <a:buNone/>
-            </a:pPr>
-            <a:r>
-              <a:rPr b="0" lang="ru-RU" sz="1400" spc="-1" strike="noStrike">
-                <a:solidFill>
-                  <a:srgbClr val="f2f2f2"/>
-                </a:solidFill>
-                <a:latin typeface="Arial"/>
-              </a:rPr>
-              <a:t>Тема:</a:t>
-            </a:r>
-            <a:endParaRPr b="0" lang="en-US" sz="1400" spc="-1" strike="noStrike">
-              <a:latin typeface="Arial"/>
-            </a:endParaRPr>
-          </a:p>
-        </p:txBody>
-      </p:sp>
     </p:spTree>
   </p:cSld>
   <mc:AlternateContent>
@@ -4080,14 +3655,14 @@
       </p:grpSpPr>
       <p:sp>
         <p:nvSpPr>
-          <p:cNvPr id="149" name="Прямоугольник со скругленными углами 3"/>
+          <p:cNvPr id="148" name="Прямоугольник со скругленными углами 3"/>
           <p:cNvSpPr/>
           <p:nvPr/>
         </p:nvSpPr>
         <p:spPr>
           <a:xfrm>
             <a:off x="186840" y="185400"/>
-            <a:ext cx="8770320" cy="4758120"/>
+            <a:ext cx="8769960" cy="4757760"/>
           </a:xfrm>
           <a:prstGeom prst="roundRect">
             <a:avLst>
@@ -4118,14 +3693,14 @@
       </p:sp>
       <p:sp>
         <p:nvSpPr>
-          <p:cNvPr id="150" name="Прямоугольник 10"/>
+          <p:cNvPr id="149" name="Прямоугольник 10"/>
           <p:cNvSpPr/>
           <p:nvPr/>
         </p:nvSpPr>
         <p:spPr>
           <a:xfrm>
             <a:off x="460080" y="658080"/>
-            <a:ext cx="8469000" cy="3306960"/>
+            <a:ext cx="8468640" cy="3306600"/>
           </a:xfrm>
           <a:prstGeom prst="rect">
             <a:avLst/>
@@ -4170,14 +3745,14 @@
       </p:sp>
       <p:sp>
         <p:nvSpPr>
-          <p:cNvPr id="151" name="Прямоугольник 5"/>
+          <p:cNvPr id="150" name="Прямоугольник 5"/>
           <p:cNvSpPr/>
           <p:nvPr/>
         </p:nvSpPr>
         <p:spPr>
           <a:xfrm>
             <a:off x="1640880" y="4497480"/>
-            <a:ext cx="2999160" cy="269640"/>
+            <a:ext cx="2998800" cy="269280"/>
           </a:xfrm>
           <a:prstGeom prst="rect">
             <a:avLst/>
@@ -4210,6 +3785,7 @@
                   <a:srgbClr val="f2f2f2"/>
                 </a:solidFill>
                 <a:latin typeface="Arial"/>
+                <a:ea typeface="DejaVu Sans"/>
               </a:rPr>
               <a:t>Презентация создана в </a:t>
             </a:r>
@@ -4219,6 +3795,7 @@
                   <a:srgbClr val="f2f2f2"/>
                 </a:solidFill>
                 <a:latin typeface="Arial"/>
+                <a:ea typeface="DejaVu Sans"/>
               </a:rPr>
               <a:t>Fibonacci</a:t>
             </a:r>
@@ -4230,14 +3807,14 @@
       </p:sp>
       <p:sp>
         <p:nvSpPr>
-          <p:cNvPr id="152" name="Изображение 40"/>
+          <p:cNvPr id="151" name="Изображение 40"/>
           <p:cNvSpPr/>
           <p:nvPr/>
         </p:nvSpPr>
         <p:spPr>
           <a:xfrm>
             <a:off x="867240" y="3495600"/>
-            <a:ext cx="257040" cy="257040"/>
+            <a:ext cx="256680" cy="256680"/>
           </a:xfrm>
           <a:prstGeom prst="ellipse">
             <a:avLst/>
@@ -4260,7 +3837,7 @@
       </p:sp>
       <p:pic>
         <p:nvPicPr>
-          <p:cNvPr id="153" name="Рисунок 12" descr=""/>
+          <p:cNvPr id="152" name="Рисунок 12" descr=""/>
           <p:cNvPicPr/>
           <p:nvPr/>
         </p:nvPicPr>
@@ -4272,7 +3849,7 @@
         <p:spPr>
           <a:xfrm>
             <a:off x="351000" y="3699000"/>
-            <a:ext cx="1289520" cy="1133640"/>
+            <a:ext cx="1289160" cy="1133280"/>
           </a:xfrm>
           <a:prstGeom prst="rect">
             <a:avLst/>
@@ -4321,14 +3898,14 @@
       </p:grpSpPr>
       <p:sp>
         <p:nvSpPr>
-          <p:cNvPr id="52" name="Прямоугольник со скругленными углами 3"/>
+          <p:cNvPr id="51" name="Прямоугольник со скругленными углами 3"/>
           <p:cNvSpPr/>
           <p:nvPr/>
         </p:nvSpPr>
         <p:spPr>
           <a:xfrm>
             <a:off x="3507480" y="0"/>
-            <a:ext cx="5636160" cy="5143320"/>
+            <a:ext cx="5635800" cy="5142960"/>
           </a:xfrm>
           <a:prstGeom prst="roundRect">
             <a:avLst>
@@ -4385,14 +3962,14 @@
       </p:sp>
       <p:sp>
         <p:nvSpPr>
-          <p:cNvPr id="53" name="Прямоугольник: скругленные углы 2"/>
+          <p:cNvPr id="52" name="Прямоугольник: скругленные углы 2"/>
           <p:cNvSpPr/>
           <p:nvPr/>
         </p:nvSpPr>
         <p:spPr>
           <a:xfrm>
             <a:off x="3722040" y="257040"/>
-            <a:ext cx="5186160" cy="4650120"/>
+            <a:ext cx="5185800" cy="4649760"/>
           </a:xfrm>
           <a:prstGeom prst="roundRect">
             <a:avLst>
@@ -4426,14 +4003,14 @@
       </p:sp>
       <p:sp>
         <p:nvSpPr>
-          <p:cNvPr id="54" name="Овал 1"/>
+          <p:cNvPr id="53" name="Овал 1"/>
           <p:cNvSpPr/>
           <p:nvPr/>
         </p:nvSpPr>
         <p:spPr>
           <a:xfrm>
             <a:off x="4122000" y="631080"/>
-            <a:ext cx="899640" cy="899640"/>
+            <a:ext cx="899280" cy="899280"/>
           </a:xfrm>
           <a:prstGeom prst="ellipse">
             <a:avLst/>
@@ -4476,6 +4053,7 @@
                   <a:srgbClr val="ffffff"/>
                 </a:solidFill>
                 <a:latin typeface="Calibri"/>
+                <a:ea typeface="DejaVu Sans"/>
               </a:rPr>
               <a:t>01</a:t>
             </a:r>
@@ -4487,14 +4065,14 @@
       </p:sp>
       <p:sp>
         <p:nvSpPr>
-          <p:cNvPr id="55" name="Овал 23"/>
+          <p:cNvPr id="54" name="Овал 23"/>
           <p:cNvSpPr/>
           <p:nvPr/>
         </p:nvSpPr>
         <p:spPr>
           <a:xfrm>
             <a:off x="4122000" y="2127600"/>
-            <a:ext cx="899640" cy="887760"/>
+            <a:ext cx="899280" cy="887400"/>
           </a:xfrm>
           <a:prstGeom prst="ellipse">
             <a:avLst/>
@@ -4537,6 +4115,7 @@
                   <a:srgbClr val="ffffff"/>
                 </a:solidFill>
                 <a:latin typeface="Calibri"/>
+                <a:ea typeface="DejaVu Sans"/>
               </a:rPr>
               <a:t>02</a:t>
             </a:r>
@@ -4548,14 +4127,14 @@
       </p:sp>
       <p:sp>
         <p:nvSpPr>
-          <p:cNvPr id="56" name="Овал 29"/>
+          <p:cNvPr id="55" name="Овал 29"/>
           <p:cNvSpPr/>
           <p:nvPr/>
         </p:nvSpPr>
         <p:spPr>
           <a:xfrm>
             <a:off x="4122000" y="3612240"/>
-            <a:ext cx="899640" cy="899640"/>
+            <a:ext cx="899280" cy="899280"/>
           </a:xfrm>
           <a:prstGeom prst="ellipse">
             <a:avLst/>
@@ -4598,6 +4177,7 @@
                   <a:srgbClr val="ffffff"/>
                 </a:solidFill>
                 <a:latin typeface="Calibri"/>
+                <a:ea typeface="DejaVu Sans"/>
               </a:rPr>
               <a:t>03</a:t>
             </a:r>
@@ -4609,14 +4189,14 @@
       </p:sp>
       <p:sp>
         <p:nvSpPr>
-          <p:cNvPr id="57" name="TextBox 10"/>
+          <p:cNvPr id="56" name="TextBox 10"/>
           <p:cNvSpPr/>
           <p:nvPr/>
         </p:nvSpPr>
         <p:spPr>
           <a:xfrm>
             <a:off x="5110920" y="489600"/>
-            <a:ext cx="3579120" cy="550800"/>
+            <a:ext cx="3578760" cy="550440"/>
           </a:xfrm>
           <a:prstGeom prst="rect">
             <a:avLst/>
@@ -4671,14 +4251,14 @@
       </p:sp>
       <p:sp>
         <p:nvSpPr>
-          <p:cNvPr id="58" name="TextBox 10"/>
+          <p:cNvPr id="57" name="TextBox 10"/>
           <p:cNvSpPr/>
           <p:nvPr/>
         </p:nvSpPr>
         <p:spPr>
           <a:xfrm>
             <a:off x="5110920" y="1025280"/>
-            <a:ext cx="3579120" cy="789840"/>
+            <a:ext cx="3578760" cy="789480"/>
           </a:xfrm>
           <a:prstGeom prst="rect">
             <a:avLst/>
@@ -4733,14 +4313,14 @@
       </p:sp>
       <p:sp>
         <p:nvSpPr>
-          <p:cNvPr id="59" name="TextBox 10"/>
+          <p:cNvPr id="58" name="TextBox 10"/>
           <p:cNvSpPr/>
           <p:nvPr/>
         </p:nvSpPr>
         <p:spPr>
           <a:xfrm>
             <a:off x="5107320" y="1985400"/>
-            <a:ext cx="3579120" cy="550800"/>
+            <a:ext cx="3578760" cy="550440"/>
           </a:xfrm>
           <a:prstGeom prst="rect">
             <a:avLst/>
@@ -4785,14 +4365,14 @@
       </p:sp>
       <p:sp>
         <p:nvSpPr>
-          <p:cNvPr id="60" name="TextBox 10"/>
+          <p:cNvPr id="59" name="TextBox 10"/>
           <p:cNvSpPr/>
           <p:nvPr/>
         </p:nvSpPr>
         <p:spPr>
           <a:xfrm>
             <a:off x="5107320" y="2517840"/>
-            <a:ext cx="3579120" cy="843480"/>
+            <a:ext cx="3578760" cy="843120"/>
           </a:xfrm>
           <a:prstGeom prst="rect">
             <a:avLst/>
@@ -4847,14 +4427,14 @@
       </p:sp>
       <p:sp>
         <p:nvSpPr>
-          <p:cNvPr id="61" name="TextBox 10"/>
+          <p:cNvPr id="60" name="TextBox 10"/>
           <p:cNvSpPr/>
           <p:nvPr/>
         </p:nvSpPr>
         <p:spPr>
           <a:xfrm>
             <a:off x="5107320" y="3470760"/>
-            <a:ext cx="3579120" cy="550800"/>
+            <a:ext cx="3578760" cy="550440"/>
           </a:xfrm>
           <a:prstGeom prst="rect">
             <a:avLst/>
@@ -4899,14 +4479,14 @@
       </p:sp>
       <p:sp>
         <p:nvSpPr>
-          <p:cNvPr id="62" name="TextBox 10"/>
+          <p:cNvPr id="61" name="TextBox 10"/>
           <p:cNvSpPr/>
           <p:nvPr/>
         </p:nvSpPr>
         <p:spPr>
           <a:xfrm>
             <a:off x="5107320" y="4003560"/>
-            <a:ext cx="3579120" cy="794880"/>
+            <a:ext cx="3578760" cy="794520"/>
           </a:xfrm>
           <a:prstGeom prst="rect">
             <a:avLst/>
@@ -4961,14 +4541,14 @@
       </p:sp>
       <p:sp>
         <p:nvSpPr>
-          <p:cNvPr id="63" name="TextBox 13"/>
+          <p:cNvPr id="62" name="TextBox 13"/>
           <p:cNvSpPr/>
           <p:nvPr/>
         </p:nvSpPr>
         <p:spPr>
           <a:xfrm>
             <a:off x="165960" y="200880"/>
-            <a:ext cx="3148200" cy="1842120"/>
+            <a:ext cx="3147840" cy="1841760"/>
           </a:xfrm>
           <a:prstGeom prst="rect">
             <a:avLst/>
@@ -5001,6 +4581,7 @@
                   <a:srgbClr val="ffffff"/>
                 </a:solidFill>
                 <a:latin typeface="Arial"/>
+                <a:ea typeface="DejaVu Sans"/>
               </a:rPr>
               <a:t>TITLE</a:t>
             </a:r>
@@ -5049,14 +4630,14 @@
       </p:grpSpPr>
       <p:sp>
         <p:nvSpPr>
-          <p:cNvPr id="64" name="Прямоугольник со скругленными углами 3"/>
+          <p:cNvPr id="63" name="Прямоугольник со скругленными углами 3"/>
           <p:cNvSpPr/>
           <p:nvPr/>
         </p:nvSpPr>
         <p:spPr>
           <a:xfrm>
             <a:off x="0" y="0"/>
-            <a:ext cx="9143640" cy="1961640"/>
+            <a:ext cx="9143280" cy="1961280"/>
           </a:xfrm>
           <a:prstGeom prst="roundRect">
             <a:avLst>
@@ -5115,14 +4696,14 @@
       </p:sp>
       <p:sp>
         <p:nvSpPr>
-          <p:cNvPr id="65" name="TextBox 10"/>
+          <p:cNvPr id="64" name="TextBox 10"/>
           <p:cNvSpPr/>
           <p:nvPr/>
         </p:nvSpPr>
         <p:spPr>
           <a:xfrm>
             <a:off x="384840" y="2571840"/>
-            <a:ext cx="2665080" cy="713880"/>
+            <a:ext cx="2664720" cy="713520"/>
           </a:xfrm>
           <a:prstGeom prst="rect">
             <a:avLst/>
@@ -5167,14 +4748,14 @@
       </p:sp>
       <p:sp>
         <p:nvSpPr>
-          <p:cNvPr id="66" name="TextBox 10"/>
+          <p:cNvPr id="65" name="TextBox 10"/>
           <p:cNvSpPr/>
           <p:nvPr/>
         </p:nvSpPr>
         <p:spPr>
           <a:xfrm>
             <a:off x="384840" y="3356280"/>
-            <a:ext cx="2665080" cy="1565280"/>
+            <a:ext cx="2664720" cy="1564920"/>
           </a:xfrm>
           <a:prstGeom prst="rect">
             <a:avLst/>
@@ -5229,14 +4810,14 @@
       </p:sp>
       <p:sp>
         <p:nvSpPr>
-          <p:cNvPr id="67" name="TextBox 10"/>
+          <p:cNvPr id="66" name="TextBox 10"/>
           <p:cNvSpPr/>
           <p:nvPr/>
         </p:nvSpPr>
         <p:spPr>
           <a:xfrm>
             <a:off x="3239280" y="2571840"/>
-            <a:ext cx="2665080" cy="713880"/>
+            <a:ext cx="2664720" cy="713520"/>
           </a:xfrm>
           <a:prstGeom prst="rect">
             <a:avLst/>
@@ -5281,14 +4862,14 @@
       </p:sp>
       <p:sp>
         <p:nvSpPr>
-          <p:cNvPr id="68" name="TextBox 10"/>
+          <p:cNvPr id="67" name="TextBox 10"/>
           <p:cNvSpPr/>
           <p:nvPr/>
         </p:nvSpPr>
         <p:spPr>
           <a:xfrm>
             <a:off x="3239280" y="3356280"/>
-            <a:ext cx="2665080" cy="1565280"/>
+            <a:ext cx="2664720" cy="1564920"/>
           </a:xfrm>
           <a:prstGeom prst="rect">
             <a:avLst/>
@@ -5343,14 +4924,14 @@
       </p:sp>
       <p:sp>
         <p:nvSpPr>
-          <p:cNvPr id="69" name="TextBox 10"/>
+          <p:cNvPr id="68" name="TextBox 10"/>
           <p:cNvSpPr/>
           <p:nvPr/>
         </p:nvSpPr>
         <p:spPr>
           <a:xfrm>
             <a:off x="6093720" y="2571840"/>
-            <a:ext cx="2665080" cy="713880"/>
+            <a:ext cx="2664720" cy="713520"/>
           </a:xfrm>
           <a:prstGeom prst="rect">
             <a:avLst/>
@@ -5395,14 +4976,14 @@
       </p:sp>
       <p:sp>
         <p:nvSpPr>
-          <p:cNvPr id="70" name="TextBox 10"/>
+          <p:cNvPr id="69" name="TextBox 10"/>
           <p:cNvSpPr/>
           <p:nvPr/>
         </p:nvSpPr>
         <p:spPr>
           <a:xfrm>
             <a:off x="6093720" y="3356280"/>
-            <a:ext cx="2665080" cy="1565280"/>
+            <a:ext cx="2664720" cy="1564920"/>
           </a:xfrm>
           <a:prstGeom prst="rect">
             <a:avLst/>
@@ -5457,14 +5038,14 @@
       </p:sp>
       <p:sp>
         <p:nvSpPr>
-          <p:cNvPr id="71" name="TextBox 9"/>
+          <p:cNvPr id="70" name="TextBox 9"/>
           <p:cNvSpPr/>
           <p:nvPr/>
         </p:nvSpPr>
         <p:spPr>
           <a:xfrm>
             <a:off x="384840" y="2178000"/>
-            <a:ext cx="8465760" cy="480960"/>
+            <a:ext cx="8465400" cy="480600"/>
           </a:xfrm>
           <a:prstGeom prst="rect">
             <a:avLst/>
@@ -5497,6 +5078,7 @@
                   <a:srgbClr val="ffffff"/>
                 </a:solidFill>
                 <a:latin typeface="Arial"/>
+                <a:ea typeface="DejaVu Sans"/>
               </a:rPr>
               <a:t>TITLE</a:t>
             </a:r>
@@ -5545,14 +5127,14 @@
       </p:grpSpPr>
       <p:sp>
         <p:nvSpPr>
-          <p:cNvPr id="72" name="Прямоугольник: скругленные углы 15"/>
+          <p:cNvPr id="71" name="Прямоугольник: скругленные углы 15"/>
           <p:cNvSpPr/>
           <p:nvPr/>
         </p:nvSpPr>
         <p:spPr>
           <a:xfrm>
             <a:off x="4636440" y="250200"/>
-            <a:ext cx="4198320" cy="4625280"/>
+            <a:ext cx="4197960" cy="4624920"/>
           </a:xfrm>
           <a:prstGeom prst="roundRect">
             <a:avLst>
@@ -5599,6 +5181,7 @@
                   <a:srgbClr val="ffffff"/>
                 </a:solidFill>
                 <a:latin typeface="Calibri"/>
+                <a:ea typeface="DejaVu Sans"/>
               </a:rPr>
               <a:t>PIC</a:t>
             </a:r>
@@ -5610,14 +5193,14 @@
       </p:sp>
       <p:sp>
         <p:nvSpPr>
-          <p:cNvPr id="73" name="Прямоугольник: скругленные углы 16"/>
+          <p:cNvPr id="72" name="Прямоугольник: скругленные углы 16"/>
           <p:cNvSpPr/>
           <p:nvPr/>
         </p:nvSpPr>
         <p:spPr>
           <a:xfrm>
             <a:off x="329400" y="257040"/>
-            <a:ext cx="4198320" cy="4625280"/>
+            <a:ext cx="4197960" cy="4624920"/>
           </a:xfrm>
           <a:prstGeom prst="roundRect">
             <a:avLst>
@@ -5651,14 +5234,14 @@
       </p:sp>
       <p:sp>
         <p:nvSpPr>
-          <p:cNvPr id="74" name="Овал 9"/>
+          <p:cNvPr id="73" name="Овал 9"/>
           <p:cNvSpPr/>
           <p:nvPr/>
         </p:nvSpPr>
         <p:spPr>
           <a:xfrm>
             <a:off x="4272120" y="1193040"/>
-            <a:ext cx="635400" cy="635400"/>
+            <a:ext cx="635040" cy="635040"/>
           </a:xfrm>
           <a:prstGeom prst="ellipse">
             <a:avLst/>
@@ -5687,14 +5270,14 @@
       </p:sp>
       <p:sp>
         <p:nvSpPr>
-          <p:cNvPr id="75" name="TextBox 10"/>
+          <p:cNvPr id="74" name="TextBox 10"/>
           <p:cNvSpPr/>
           <p:nvPr/>
         </p:nvSpPr>
         <p:spPr>
           <a:xfrm>
             <a:off x="581760" y="828720"/>
-            <a:ext cx="3693600" cy="550800"/>
+            <a:ext cx="3693240" cy="550440"/>
           </a:xfrm>
           <a:prstGeom prst="rect">
             <a:avLst/>
@@ -5749,14 +5332,14 @@
       </p:sp>
       <p:sp>
         <p:nvSpPr>
-          <p:cNvPr id="76" name="TextBox 10"/>
+          <p:cNvPr id="75" name="TextBox 10"/>
           <p:cNvSpPr/>
           <p:nvPr/>
         </p:nvSpPr>
         <p:spPr>
           <a:xfrm>
             <a:off x="581760" y="1364400"/>
-            <a:ext cx="3693600" cy="789840"/>
+            <a:ext cx="3693240" cy="789480"/>
           </a:xfrm>
           <a:prstGeom prst="rect">
             <a:avLst/>
@@ -5811,14 +5394,14 @@
       </p:sp>
       <p:sp>
         <p:nvSpPr>
-          <p:cNvPr id="77" name="TextBox 10"/>
+          <p:cNvPr id="76" name="TextBox 10"/>
           <p:cNvSpPr/>
           <p:nvPr/>
         </p:nvSpPr>
         <p:spPr>
           <a:xfrm>
             <a:off x="578160" y="2154600"/>
-            <a:ext cx="3693600" cy="550800"/>
+            <a:ext cx="3693240" cy="550440"/>
           </a:xfrm>
           <a:prstGeom prst="rect">
             <a:avLst/>
@@ -5863,14 +5446,14 @@
       </p:sp>
       <p:sp>
         <p:nvSpPr>
-          <p:cNvPr id="78" name="TextBox 10"/>
+          <p:cNvPr id="77" name="TextBox 10"/>
           <p:cNvSpPr/>
           <p:nvPr/>
         </p:nvSpPr>
         <p:spPr>
           <a:xfrm>
             <a:off x="578160" y="2687040"/>
-            <a:ext cx="3693600" cy="843480"/>
+            <a:ext cx="3693240" cy="843120"/>
           </a:xfrm>
           <a:prstGeom prst="rect">
             <a:avLst/>
@@ -5925,14 +5508,14 @@
       </p:sp>
       <p:sp>
         <p:nvSpPr>
-          <p:cNvPr id="79" name="TextBox 10"/>
+          <p:cNvPr id="78" name="TextBox 10"/>
           <p:cNvSpPr/>
           <p:nvPr/>
         </p:nvSpPr>
         <p:spPr>
           <a:xfrm>
             <a:off x="578160" y="3482280"/>
-            <a:ext cx="3693600" cy="550800"/>
+            <a:ext cx="3693240" cy="550440"/>
           </a:xfrm>
           <a:prstGeom prst="rect">
             <a:avLst/>
@@ -5977,14 +5560,14 @@
       </p:sp>
       <p:sp>
         <p:nvSpPr>
-          <p:cNvPr id="80" name="TextBox 10"/>
+          <p:cNvPr id="79" name="TextBox 10"/>
           <p:cNvSpPr/>
           <p:nvPr/>
         </p:nvSpPr>
         <p:spPr>
           <a:xfrm>
             <a:off x="578160" y="4015080"/>
-            <a:ext cx="3693600" cy="794880"/>
+            <a:ext cx="3693240" cy="794520"/>
           </a:xfrm>
           <a:prstGeom prst="rect">
             <a:avLst/>
@@ -6039,14 +5622,14 @@
       </p:sp>
       <p:sp>
         <p:nvSpPr>
-          <p:cNvPr id="81" name="TextBox 30"/>
+          <p:cNvPr id="80" name="TextBox 30"/>
           <p:cNvSpPr/>
           <p:nvPr/>
         </p:nvSpPr>
         <p:spPr>
           <a:xfrm>
             <a:off x="553680" y="352440"/>
-            <a:ext cx="3803760" cy="789840"/>
+            <a:ext cx="3803400" cy="789480"/>
           </a:xfrm>
           <a:prstGeom prst="rect">
             <a:avLst/>
@@ -6079,6 +5662,7 @@
                   <a:srgbClr val="ffffff"/>
                 </a:solidFill>
                 <a:latin typeface="Arial"/>
+                <a:ea typeface="DejaVu Sans"/>
               </a:rPr>
               <a:t>TITLE</a:t>
             </a:r>
@@ -6127,14 +5711,14 @@
       </p:grpSpPr>
       <p:sp>
         <p:nvSpPr>
-          <p:cNvPr id="82" name="TextBox 20"/>
+          <p:cNvPr id="81" name="TextBox 20"/>
           <p:cNvSpPr/>
           <p:nvPr/>
         </p:nvSpPr>
         <p:spPr>
           <a:xfrm>
             <a:off x="516960" y="411840"/>
-            <a:ext cx="8465760" cy="480960"/>
+            <a:ext cx="8465400" cy="480600"/>
           </a:xfrm>
           <a:prstGeom prst="rect">
             <a:avLst/>
@@ -6167,6 +5751,7 @@
                   <a:srgbClr val="ffffff"/>
                 </a:solidFill>
                 <a:latin typeface="Arial"/>
+                <a:ea typeface="DejaVu Sans"/>
               </a:rPr>
               <a:t>TITLE</a:t>
             </a:r>
@@ -6178,14 +5763,14 @@
       </p:sp>
       <p:sp>
         <p:nvSpPr>
-          <p:cNvPr id="83" name="Прямоугольник со скругленными углами 3"/>
+          <p:cNvPr id="82" name="Прямоугольник со скругленными углами 3"/>
           <p:cNvSpPr/>
           <p:nvPr/>
         </p:nvSpPr>
         <p:spPr>
           <a:xfrm>
             <a:off x="456480" y="1406160"/>
-            <a:ext cx="2300760" cy="1440000"/>
+            <a:ext cx="2300400" cy="1439640"/>
           </a:xfrm>
           <a:prstGeom prst="roundRect">
             <a:avLst>
@@ -6244,14 +5829,14 @@
       </p:sp>
       <p:sp>
         <p:nvSpPr>
-          <p:cNvPr id="84" name="TextBox 10"/>
+          <p:cNvPr id="83" name="TextBox 10"/>
           <p:cNvSpPr/>
           <p:nvPr/>
         </p:nvSpPr>
         <p:spPr>
           <a:xfrm>
             <a:off x="384840" y="3013560"/>
-            <a:ext cx="2429280" cy="713880"/>
+            <a:ext cx="2428920" cy="713520"/>
           </a:xfrm>
           <a:prstGeom prst="rect">
             <a:avLst/>
@@ -6296,14 +5881,14 @@
       </p:sp>
       <p:sp>
         <p:nvSpPr>
-          <p:cNvPr id="85" name="TextBox 10"/>
+          <p:cNvPr id="84" name="TextBox 10"/>
           <p:cNvSpPr/>
           <p:nvPr/>
         </p:nvSpPr>
         <p:spPr>
           <a:xfrm>
             <a:off x="384840" y="3798000"/>
-            <a:ext cx="2429280" cy="1037880"/>
+            <a:ext cx="2428920" cy="1037520"/>
           </a:xfrm>
           <a:prstGeom prst="rect">
             <a:avLst/>
@@ -6358,14 +5943,14 @@
       </p:sp>
       <p:sp>
         <p:nvSpPr>
-          <p:cNvPr id="86" name="Прямоугольник: скругленные углы 1"/>
+          <p:cNvPr id="85" name="Прямоугольник: скругленные углы 1"/>
           <p:cNvSpPr/>
           <p:nvPr/>
         </p:nvSpPr>
         <p:spPr>
           <a:xfrm>
             <a:off x="328680" y="228600"/>
-            <a:ext cx="8501400" cy="813960"/>
+            <a:ext cx="8501040" cy="813600"/>
           </a:xfrm>
           <a:prstGeom prst="roundRect">
             <a:avLst>
@@ -6396,14 +5981,14 @@
       </p:sp>
       <p:sp>
         <p:nvSpPr>
-          <p:cNvPr id="87" name="Прямоугольник: скругленные углы 10"/>
+          <p:cNvPr id="86" name="Прямоугольник: скругленные углы 10"/>
           <p:cNvSpPr/>
           <p:nvPr/>
         </p:nvSpPr>
         <p:spPr>
           <a:xfrm>
             <a:off x="328680" y="1279080"/>
-            <a:ext cx="2557080" cy="3642840"/>
+            <a:ext cx="2556720" cy="3642480"/>
           </a:xfrm>
           <a:prstGeom prst="roundRect">
             <a:avLst>
@@ -6434,14 +6019,14 @@
       </p:sp>
       <p:sp>
         <p:nvSpPr>
-          <p:cNvPr id="88" name="Прямоугольник со скругленными углами 3"/>
+          <p:cNvPr id="87" name="Прямоугольник со скругленными углами 3"/>
           <p:cNvSpPr/>
           <p:nvPr/>
         </p:nvSpPr>
         <p:spPr>
           <a:xfrm>
             <a:off x="3421080" y="1398960"/>
-            <a:ext cx="2300760" cy="1440000"/>
+            <a:ext cx="2300400" cy="1439640"/>
           </a:xfrm>
           <a:prstGeom prst="roundRect">
             <a:avLst>
@@ -6500,14 +6085,14 @@
       </p:sp>
       <p:sp>
         <p:nvSpPr>
-          <p:cNvPr id="89" name="TextBox 10"/>
+          <p:cNvPr id="88" name="TextBox 10"/>
           <p:cNvSpPr/>
           <p:nvPr/>
         </p:nvSpPr>
         <p:spPr>
           <a:xfrm>
             <a:off x="3349440" y="3013560"/>
-            <a:ext cx="2429280" cy="713880"/>
+            <a:ext cx="2428920" cy="713520"/>
           </a:xfrm>
           <a:prstGeom prst="rect">
             <a:avLst/>
@@ -6562,14 +6147,14 @@
       </p:sp>
       <p:sp>
         <p:nvSpPr>
-          <p:cNvPr id="90" name="TextBox 10"/>
+          <p:cNvPr id="89" name="TextBox 10"/>
           <p:cNvSpPr/>
           <p:nvPr/>
         </p:nvSpPr>
         <p:spPr>
           <a:xfrm>
             <a:off x="3349440" y="3798000"/>
-            <a:ext cx="2429280" cy="1037880"/>
+            <a:ext cx="2428920" cy="1037520"/>
           </a:xfrm>
           <a:prstGeom prst="rect">
             <a:avLst/>
@@ -6624,14 +6209,14 @@
       </p:sp>
       <p:sp>
         <p:nvSpPr>
-          <p:cNvPr id="91" name="Прямоугольник: скругленные углы 14"/>
+          <p:cNvPr id="90" name="Прямоугольник: скругленные углы 14"/>
           <p:cNvSpPr/>
           <p:nvPr/>
         </p:nvSpPr>
         <p:spPr>
           <a:xfrm>
             <a:off x="3293280" y="1271880"/>
-            <a:ext cx="2557080" cy="3642840"/>
+            <a:ext cx="2556720" cy="3642480"/>
           </a:xfrm>
           <a:prstGeom prst="roundRect">
             <a:avLst>
@@ -6662,14 +6247,14 @@
       </p:sp>
       <p:sp>
         <p:nvSpPr>
-          <p:cNvPr id="92" name="Прямоугольник со скругленными углами 3"/>
+          <p:cNvPr id="91" name="Прямоугольник со скругленными углами 3"/>
           <p:cNvSpPr/>
           <p:nvPr/>
         </p:nvSpPr>
         <p:spPr>
           <a:xfrm>
             <a:off x="6400800" y="1379520"/>
-            <a:ext cx="2300760" cy="1440000"/>
+            <a:ext cx="2300400" cy="1439640"/>
           </a:xfrm>
           <a:prstGeom prst="roundRect">
             <a:avLst>
@@ -6728,14 +6313,14 @@
       </p:sp>
       <p:sp>
         <p:nvSpPr>
-          <p:cNvPr id="93" name="TextBox 10"/>
+          <p:cNvPr id="92" name="TextBox 10"/>
           <p:cNvSpPr/>
           <p:nvPr/>
         </p:nvSpPr>
         <p:spPr>
           <a:xfrm>
             <a:off x="6329520" y="3013560"/>
-            <a:ext cx="2429280" cy="713880"/>
+            <a:ext cx="2428920" cy="713520"/>
           </a:xfrm>
           <a:prstGeom prst="rect">
             <a:avLst/>
@@ -6790,14 +6375,14 @@
       </p:sp>
       <p:sp>
         <p:nvSpPr>
-          <p:cNvPr id="94" name="TextBox 10"/>
+          <p:cNvPr id="93" name="TextBox 10"/>
           <p:cNvSpPr/>
           <p:nvPr/>
         </p:nvSpPr>
         <p:spPr>
           <a:xfrm>
             <a:off x="6329520" y="3798000"/>
-            <a:ext cx="2429280" cy="1037880"/>
+            <a:ext cx="2428920" cy="1037520"/>
           </a:xfrm>
           <a:prstGeom prst="rect">
             <a:avLst/>
@@ -6852,14 +6437,14 @@
       </p:sp>
       <p:sp>
         <p:nvSpPr>
-          <p:cNvPr id="95" name="Прямоугольник: скругленные углы 19"/>
+          <p:cNvPr id="94" name="Прямоугольник: скругленные углы 19"/>
           <p:cNvSpPr/>
           <p:nvPr/>
         </p:nvSpPr>
         <p:spPr>
           <a:xfrm>
             <a:off x="6273000" y="1252800"/>
-            <a:ext cx="2557080" cy="3642840"/>
+            <a:ext cx="2556720" cy="3642480"/>
           </a:xfrm>
           <a:prstGeom prst="roundRect">
             <a:avLst>
@@ -6927,14 +6512,14 @@
       </p:grpSpPr>
       <p:sp>
         <p:nvSpPr>
-          <p:cNvPr id="96" name="Прямоугольник со скругленными углами 3"/>
+          <p:cNvPr id="95" name="Прямоугольник со скругленными углами 3"/>
           <p:cNvSpPr/>
           <p:nvPr/>
         </p:nvSpPr>
         <p:spPr>
           <a:xfrm>
             <a:off x="0" y="0"/>
-            <a:ext cx="3396960" cy="5143320"/>
+            <a:ext cx="3396600" cy="5142960"/>
           </a:xfrm>
           <a:prstGeom prst="roundRect">
             <a:avLst>
@@ -6993,14 +6578,14 @@
       </p:sp>
       <p:sp>
         <p:nvSpPr>
-          <p:cNvPr id="97" name="TextBox 10"/>
+          <p:cNvPr id="96" name="TextBox 10"/>
           <p:cNvSpPr/>
           <p:nvPr/>
         </p:nvSpPr>
         <p:spPr>
           <a:xfrm>
             <a:off x="4192560" y="3830040"/>
-            <a:ext cx="4672440" cy="329040"/>
+            <a:ext cx="4672080" cy="328680"/>
           </a:xfrm>
           <a:prstGeom prst="rect">
             <a:avLst/>
@@ -7045,14 +6630,14 @@
       </p:sp>
       <p:sp>
         <p:nvSpPr>
-          <p:cNvPr id="98" name="TextBox 10"/>
+          <p:cNvPr id="97" name="TextBox 10"/>
           <p:cNvSpPr/>
           <p:nvPr/>
         </p:nvSpPr>
         <p:spPr>
           <a:xfrm>
             <a:off x="4192560" y="4188600"/>
-            <a:ext cx="4672440" cy="713880"/>
+            <a:ext cx="4672080" cy="713520"/>
           </a:xfrm>
           <a:prstGeom prst="rect">
             <a:avLst/>
@@ -7107,14 +6692,14 @@
       </p:sp>
       <p:sp>
         <p:nvSpPr>
-          <p:cNvPr id="99" name="Овал 9"/>
+          <p:cNvPr id="98" name="Овал 9"/>
           <p:cNvSpPr/>
           <p:nvPr/>
         </p:nvSpPr>
         <p:spPr>
           <a:xfrm>
             <a:off x="3724560" y="3830040"/>
-            <a:ext cx="403200" cy="403200"/>
+            <a:ext cx="402840" cy="402840"/>
           </a:xfrm>
           <a:prstGeom prst="ellipse">
             <a:avLst/>
@@ -7157,6 +6742,7 @@
                   <a:srgbClr val="ffffff"/>
                 </a:solidFill>
                 <a:latin typeface="Calibri"/>
+                <a:ea typeface="DejaVu Sans"/>
               </a:rPr>
               <a:t>03</a:t>
             </a:r>
@@ -7168,14 +6754,14 @@
       </p:sp>
       <p:sp>
         <p:nvSpPr>
-          <p:cNvPr id="100" name="TextBox 10"/>
+          <p:cNvPr id="99" name="TextBox 10"/>
           <p:cNvSpPr/>
           <p:nvPr/>
         </p:nvSpPr>
         <p:spPr>
           <a:xfrm>
             <a:off x="4192560" y="2571840"/>
-            <a:ext cx="4672440" cy="329040"/>
+            <a:ext cx="4672080" cy="328680"/>
           </a:xfrm>
           <a:prstGeom prst="rect">
             <a:avLst/>
@@ -7230,14 +6816,14 @@
       </p:sp>
       <p:sp>
         <p:nvSpPr>
-          <p:cNvPr id="101" name="TextBox 10"/>
+          <p:cNvPr id="100" name="TextBox 10"/>
           <p:cNvSpPr/>
           <p:nvPr/>
         </p:nvSpPr>
         <p:spPr>
           <a:xfrm>
             <a:off x="4192560" y="2930400"/>
-            <a:ext cx="4672440" cy="713880"/>
+            <a:ext cx="4672080" cy="713520"/>
           </a:xfrm>
           <a:prstGeom prst="rect">
             <a:avLst/>
@@ -7292,14 +6878,14 @@
       </p:sp>
       <p:sp>
         <p:nvSpPr>
-          <p:cNvPr id="102" name="Овал 13"/>
+          <p:cNvPr id="101" name="Овал 13"/>
           <p:cNvSpPr/>
           <p:nvPr/>
         </p:nvSpPr>
         <p:spPr>
           <a:xfrm>
             <a:off x="3724560" y="2571840"/>
-            <a:ext cx="403200" cy="403200"/>
+            <a:ext cx="402840" cy="402840"/>
           </a:xfrm>
           <a:prstGeom prst="ellipse">
             <a:avLst/>
@@ -7342,6 +6928,7 @@
                   <a:srgbClr val="ffffff"/>
                 </a:solidFill>
                 <a:latin typeface="Calibri"/>
+                <a:ea typeface="DejaVu Sans"/>
               </a:rPr>
               <a:t>02</a:t>
             </a:r>
@@ -7353,14 +6940,14 @@
       </p:sp>
       <p:sp>
         <p:nvSpPr>
-          <p:cNvPr id="103" name="TextBox 10"/>
+          <p:cNvPr id="102" name="TextBox 10"/>
           <p:cNvSpPr/>
           <p:nvPr/>
         </p:nvSpPr>
         <p:spPr>
           <a:xfrm>
             <a:off x="4192560" y="1311840"/>
-            <a:ext cx="4672440" cy="329040"/>
+            <a:ext cx="4672080" cy="328680"/>
           </a:xfrm>
           <a:prstGeom prst="rect">
             <a:avLst/>
@@ -7415,14 +7002,14 @@
       </p:sp>
       <p:sp>
         <p:nvSpPr>
-          <p:cNvPr id="104" name="TextBox 10"/>
+          <p:cNvPr id="103" name="TextBox 10"/>
           <p:cNvSpPr/>
           <p:nvPr/>
         </p:nvSpPr>
         <p:spPr>
           <a:xfrm>
             <a:off x="4192560" y="1670760"/>
-            <a:ext cx="4672440" cy="713880"/>
+            <a:ext cx="4672080" cy="713520"/>
           </a:xfrm>
           <a:prstGeom prst="rect">
             <a:avLst/>
@@ -7477,14 +7064,14 @@
       </p:sp>
       <p:sp>
         <p:nvSpPr>
-          <p:cNvPr id="105" name="Овал 16"/>
+          <p:cNvPr id="104" name="Овал 16"/>
           <p:cNvSpPr/>
           <p:nvPr/>
         </p:nvSpPr>
         <p:spPr>
           <a:xfrm>
             <a:off x="3724560" y="1311840"/>
-            <a:ext cx="403200" cy="403200"/>
+            <a:ext cx="402840" cy="402840"/>
           </a:xfrm>
           <a:prstGeom prst="ellipse">
             <a:avLst/>
@@ -7527,6 +7114,7 @@
                   <a:srgbClr val="ffffff"/>
                 </a:solidFill>
                 <a:latin typeface="Calibri"/>
+                <a:ea typeface="DejaVu Sans"/>
               </a:rPr>
               <a:t>01</a:t>
             </a:r>
@@ -7538,14 +7126,14 @@
       </p:sp>
       <p:sp>
         <p:nvSpPr>
-          <p:cNvPr id="106" name="TextBox 17"/>
+          <p:cNvPr id="105" name="TextBox 17"/>
           <p:cNvSpPr/>
           <p:nvPr/>
         </p:nvSpPr>
         <p:spPr>
           <a:xfrm>
             <a:off x="3607560" y="215280"/>
-            <a:ext cx="5375160" cy="909720"/>
+            <a:ext cx="5374800" cy="909360"/>
           </a:xfrm>
           <a:prstGeom prst="rect">
             <a:avLst/>
@@ -7578,6 +7166,7 @@
                   <a:srgbClr val="ffffff"/>
                 </a:solidFill>
                 <a:latin typeface="Arial"/>
+                <a:ea typeface="DejaVu Sans"/>
               </a:rPr>
               <a:t>TITLE</a:t>
             </a:r>
@@ -7626,14 +7215,14 @@
       </p:grpSpPr>
       <p:sp>
         <p:nvSpPr>
-          <p:cNvPr id="107" name="Прямоугольник: скругленные углы 22"/>
+          <p:cNvPr id="106" name="Прямоугольник: скругленные углы 22"/>
           <p:cNvSpPr/>
           <p:nvPr/>
         </p:nvSpPr>
         <p:spPr>
           <a:xfrm>
             <a:off x="3417120" y="1051560"/>
-            <a:ext cx="5047920" cy="841680"/>
+            <a:ext cx="5047560" cy="841320"/>
           </a:xfrm>
           <a:prstGeom prst="roundRect">
             <a:avLst>
@@ -7664,14 +7253,14 @@
       </p:sp>
       <p:sp>
         <p:nvSpPr>
-          <p:cNvPr id="108" name="Прямоугольник: скругленные углы 28"/>
+          <p:cNvPr id="107" name="Прямоугольник: скругленные углы 28"/>
           <p:cNvSpPr/>
           <p:nvPr/>
         </p:nvSpPr>
         <p:spPr>
           <a:xfrm>
             <a:off x="3417120" y="2451960"/>
-            <a:ext cx="5047920" cy="841680"/>
+            <a:ext cx="5047560" cy="841320"/>
           </a:xfrm>
           <a:prstGeom prst="roundRect">
             <a:avLst>
@@ -7702,14 +7291,14 @@
       </p:sp>
       <p:sp>
         <p:nvSpPr>
-          <p:cNvPr id="109" name="Прямоугольник: скругленные углы 32"/>
+          <p:cNvPr id="108" name="Прямоугольник: скругленные углы 32"/>
           <p:cNvSpPr/>
           <p:nvPr/>
         </p:nvSpPr>
         <p:spPr>
           <a:xfrm>
             <a:off x="3417120" y="3849840"/>
-            <a:ext cx="5047920" cy="841680"/>
+            <a:ext cx="5047560" cy="841320"/>
           </a:xfrm>
           <a:prstGeom prst="roundRect">
             <a:avLst>
@@ -7740,14 +7329,14 @@
       </p:sp>
       <p:sp>
         <p:nvSpPr>
-          <p:cNvPr id="110" name="TextBox 10"/>
+          <p:cNvPr id="109" name="TextBox 10"/>
           <p:cNvSpPr/>
           <p:nvPr/>
         </p:nvSpPr>
         <p:spPr>
           <a:xfrm>
             <a:off x="3821760" y="1115280"/>
-            <a:ext cx="4483800" cy="713880"/>
+            <a:ext cx="4483440" cy="713520"/>
           </a:xfrm>
           <a:prstGeom prst="rect">
             <a:avLst/>
@@ -7802,7 +7391,7 @@
       </p:sp>
       <p:sp>
         <p:nvSpPr>
-          <p:cNvPr id="111" name="Прямая соединительная линия 4"/>
+          <p:cNvPr id="110" name="Прямая соединительная линия 4"/>
           <p:cNvSpPr/>
           <p:nvPr/>
         </p:nvSpPr>
@@ -7835,14 +7424,14 @@
       </p:sp>
       <p:sp>
         <p:nvSpPr>
-          <p:cNvPr id="112" name="Прямоугольник: скругленные углы 19"/>
+          <p:cNvPr id="111" name="Прямоугольник: скругленные углы 19"/>
           <p:cNvSpPr/>
           <p:nvPr/>
         </p:nvSpPr>
         <p:spPr>
           <a:xfrm>
             <a:off x="1135800" y="1033200"/>
-            <a:ext cx="2642760" cy="880920"/>
+            <a:ext cx="2642400" cy="880560"/>
           </a:xfrm>
           <a:prstGeom prst="roundRect">
             <a:avLst>
@@ -7873,14 +7462,14 @@
       </p:sp>
       <p:sp>
         <p:nvSpPr>
-          <p:cNvPr id="113" name="TextBox 10"/>
+          <p:cNvPr id="112" name="TextBox 10"/>
           <p:cNvSpPr/>
           <p:nvPr/>
         </p:nvSpPr>
         <p:spPr>
           <a:xfrm>
             <a:off x="1164600" y="1033200"/>
-            <a:ext cx="2546280" cy="880920"/>
+            <a:ext cx="2545920" cy="880560"/>
           </a:xfrm>
           <a:prstGeom prst="rect">
             <a:avLst/>
@@ -7935,14 +7524,14 @@
       </p:sp>
       <p:sp>
         <p:nvSpPr>
-          <p:cNvPr id="114" name="TextBox 10"/>
+          <p:cNvPr id="113" name="TextBox 10"/>
           <p:cNvSpPr/>
           <p:nvPr/>
         </p:nvSpPr>
         <p:spPr>
           <a:xfrm>
             <a:off x="3821760" y="2515680"/>
-            <a:ext cx="4483800" cy="713880"/>
+            <a:ext cx="4483440" cy="713520"/>
           </a:xfrm>
           <a:prstGeom prst="rect">
             <a:avLst/>
@@ -7997,14 +7586,14 @@
       </p:sp>
       <p:sp>
         <p:nvSpPr>
-          <p:cNvPr id="115" name="Прямоугольник: скругленные углы 26"/>
+          <p:cNvPr id="114" name="Прямоугольник: скругленные углы 26"/>
           <p:cNvSpPr/>
           <p:nvPr/>
         </p:nvSpPr>
         <p:spPr>
           <a:xfrm>
             <a:off x="1135800" y="2433600"/>
-            <a:ext cx="2642760" cy="880920"/>
+            <a:ext cx="2642400" cy="880560"/>
           </a:xfrm>
           <a:prstGeom prst="roundRect">
             <a:avLst>
@@ -8035,14 +7624,14 @@
       </p:sp>
       <p:sp>
         <p:nvSpPr>
-          <p:cNvPr id="116" name="TextBox 10"/>
+          <p:cNvPr id="115" name="TextBox 10"/>
           <p:cNvSpPr/>
           <p:nvPr/>
         </p:nvSpPr>
         <p:spPr>
           <a:xfrm>
             <a:off x="1164600" y="2433600"/>
-            <a:ext cx="2546280" cy="880920"/>
+            <a:ext cx="2545920" cy="880560"/>
           </a:xfrm>
           <a:prstGeom prst="rect">
             <a:avLst/>
@@ -8097,14 +7686,14 @@
       </p:sp>
       <p:sp>
         <p:nvSpPr>
-          <p:cNvPr id="117" name="TextBox 10"/>
+          <p:cNvPr id="116" name="TextBox 10"/>
           <p:cNvSpPr/>
           <p:nvPr/>
         </p:nvSpPr>
         <p:spPr>
           <a:xfrm>
             <a:off x="3821760" y="3913560"/>
-            <a:ext cx="4483800" cy="713880"/>
+            <a:ext cx="4483440" cy="713520"/>
           </a:xfrm>
           <a:prstGeom prst="rect">
             <a:avLst/>
@@ -8159,14 +7748,14 @@
       </p:sp>
       <p:sp>
         <p:nvSpPr>
-          <p:cNvPr id="118" name="Прямоугольник: скругленные углы 30"/>
+          <p:cNvPr id="117" name="Прямоугольник: скругленные углы 30"/>
           <p:cNvSpPr/>
           <p:nvPr/>
         </p:nvSpPr>
         <p:spPr>
           <a:xfrm>
             <a:off x="1135800" y="3831480"/>
-            <a:ext cx="2642760" cy="880920"/>
+            <a:ext cx="2642400" cy="880560"/>
           </a:xfrm>
           <a:prstGeom prst="roundRect">
             <a:avLst>
@@ -8197,14 +7786,14 @@
       </p:sp>
       <p:sp>
         <p:nvSpPr>
-          <p:cNvPr id="119" name="TextBox 10"/>
+          <p:cNvPr id="118" name="TextBox 10"/>
           <p:cNvSpPr/>
           <p:nvPr/>
         </p:nvSpPr>
         <p:spPr>
           <a:xfrm>
             <a:off x="1164600" y="3831480"/>
-            <a:ext cx="2546280" cy="880920"/>
+            <a:ext cx="2545920" cy="880560"/>
           </a:xfrm>
           <a:prstGeom prst="rect">
             <a:avLst/>
@@ -8259,14 +7848,14 @@
       </p:sp>
       <p:sp>
         <p:nvSpPr>
-          <p:cNvPr id="120" name="Овал 5"/>
+          <p:cNvPr id="119" name="Овал 5"/>
           <p:cNvSpPr/>
           <p:nvPr/>
         </p:nvSpPr>
         <p:spPr>
           <a:xfrm>
             <a:off x="675360" y="1365840"/>
-            <a:ext cx="221040" cy="221040"/>
+            <a:ext cx="220680" cy="220680"/>
           </a:xfrm>
           <a:prstGeom prst="ellipse">
             <a:avLst/>
@@ -8300,14 +7889,14 @@
       </p:sp>
       <p:sp>
         <p:nvSpPr>
-          <p:cNvPr id="121" name="Овал 33"/>
+          <p:cNvPr id="120" name="Овал 33"/>
           <p:cNvSpPr/>
           <p:nvPr/>
         </p:nvSpPr>
         <p:spPr>
           <a:xfrm>
             <a:off x="675360" y="2728080"/>
-            <a:ext cx="221040" cy="221040"/>
+            <a:ext cx="220680" cy="220680"/>
           </a:xfrm>
           <a:prstGeom prst="ellipse">
             <a:avLst/>
@@ -8341,14 +7930,14 @@
       </p:sp>
       <p:sp>
         <p:nvSpPr>
-          <p:cNvPr id="122" name="Овал 34"/>
+          <p:cNvPr id="121" name="Овал 34"/>
           <p:cNvSpPr/>
           <p:nvPr/>
         </p:nvSpPr>
         <p:spPr>
           <a:xfrm>
             <a:off x="671760" y="4156200"/>
-            <a:ext cx="221040" cy="221040"/>
+            <a:ext cx="220680" cy="220680"/>
           </a:xfrm>
           <a:prstGeom prst="ellipse">
             <a:avLst/>
@@ -8382,14 +7971,14 @@
       </p:sp>
       <p:sp>
         <p:nvSpPr>
-          <p:cNvPr id="123" name="TextBox 20"/>
+          <p:cNvPr id="122" name="TextBox 20"/>
           <p:cNvSpPr/>
           <p:nvPr/>
         </p:nvSpPr>
         <p:spPr>
           <a:xfrm>
             <a:off x="381600" y="271080"/>
-            <a:ext cx="8465760" cy="480960"/>
+            <a:ext cx="8465400" cy="480600"/>
           </a:xfrm>
           <a:prstGeom prst="rect">
             <a:avLst/>
@@ -8422,6 +8011,7 @@
                   <a:srgbClr val="ffffff"/>
                 </a:solidFill>
                 <a:latin typeface="Arial"/>
+                <a:ea typeface="DejaVu Sans"/>
               </a:rPr>
               <a:t>TITLE</a:t>
             </a:r>
@@ -8470,14 +8060,14 @@
       </p:grpSpPr>
       <p:sp>
         <p:nvSpPr>
-          <p:cNvPr id="124" name="Прямоугольник со скругленными углами 3"/>
+          <p:cNvPr id="123" name="Прямоугольник со скругленными углами 3"/>
           <p:cNvSpPr/>
           <p:nvPr/>
         </p:nvSpPr>
         <p:spPr>
           <a:xfrm>
             <a:off x="0" y="3181680"/>
-            <a:ext cx="9143640" cy="1961640"/>
+            <a:ext cx="9143280" cy="1961280"/>
           </a:xfrm>
           <a:prstGeom prst="roundRect">
             <a:avLst>
@@ -8536,14 +8126,14 @@
       </p:sp>
       <p:sp>
         <p:nvSpPr>
-          <p:cNvPr id="125" name="TextBox 10"/>
+          <p:cNvPr id="124" name="TextBox 10"/>
           <p:cNvSpPr/>
           <p:nvPr/>
         </p:nvSpPr>
         <p:spPr>
           <a:xfrm>
             <a:off x="384840" y="801360"/>
-            <a:ext cx="2443680" cy="713880"/>
+            <a:ext cx="2443320" cy="713520"/>
           </a:xfrm>
           <a:prstGeom prst="rect">
             <a:avLst/>
@@ -8588,14 +8178,14 @@
       </p:sp>
       <p:sp>
         <p:nvSpPr>
-          <p:cNvPr id="126" name="TextBox 10"/>
+          <p:cNvPr id="125" name="TextBox 10"/>
           <p:cNvSpPr/>
           <p:nvPr/>
         </p:nvSpPr>
         <p:spPr>
           <a:xfrm>
             <a:off x="384840" y="1585800"/>
-            <a:ext cx="2443680" cy="1565280"/>
+            <a:ext cx="2443320" cy="1564920"/>
           </a:xfrm>
           <a:prstGeom prst="rect">
             <a:avLst/>
@@ -8650,14 +8240,14 @@
       </p:sp>
       <p:sp>
         <p:nvSpPr>
-          <p:cNvPr id="127" name="TextBox 10"/>
+          <p:cNvPr id="126" name="TextBox 10"/>
           <p:cNvSpPr/>
           <p:nvPr/>
         </p:nvSpPr>
         <p:spPr>
           <a:xfrm>
             <a:off x="3269880" y="801360"/>
-            <a:ext cx="2443680" cy="713880"/>
+            <a:ext cx="2443320" cy="713520"/>
           </a:xfrm>
           <a:prstGeom prst="rect">
             <a:avLst/>
@@ -8702,14 +8292,14 @@
       </p:sp>
       <p:sp>
         <p:nvSpPr>
-          <p:cNvPr id="128" name="TextBox 10"/>
+          <p:cNvPr id="127" name="TextBox 10"/>
           <p:cNvSpPr/>
           <p:nvPr/>
         </p:nvSpPr>
         <p:spPr>
           <a:xfrm>
             <a:off x="3269880" y="1585800"/>
-            <a:ext cx="2443680" cy="1565280"/>
+            <a:ext cx="2443320" cy="1564920"/>
           </a:xfrm>
           <a:prstGeom prst="rect">
             <a:avLst/>
@@ -8764,14 +8354,14 @@
       </p:sp>
       <p:sp>
         <p:nvSpPr>
-          <p:cNvPr id="129" name="TextBox 10"/>
+          <p:cNvPr id="128" name="TextBox 10"/>
           <p:cNvSpPr/>
           <p:nvPr/>
         </p:nvSpPr>
         <p:spPr>
           <a:xfrm>
             <a:off x="6154560" y="801360"/>
-            <a:ext cx="2665080" cy="713880"/>
+            <a:ext cx="2664720" cy="713520"/>
           </a:xfrm>
           <a:prstGeom prst="rect">
             <a:avLst/>
@@ -8816,14 +8406,14 @@
       </p:sp>
       <p:sp>
         <p:nvSpPr>
-          <p:cNvPr id="130" name="TextBox 10"/>
+          <p:cNvPr id="129" name="TextBox 10"/>
           <p:cNvSpPr/>
           <p:nvPr/>
         </p:nvSpPr>
         <p:spPr>
           <a:xfrm>
             <a:off x="6154560" y="1585800"/>
-            <a:ext cx="2665080" cy="1565280"/>
+            <a:ext cx="2664720" cy="1564920"/>
           </a:xfrm>
           <a:prstGeom prst="rect">
             <a:avLst/>
@@ -8878,7 +8468,7 @@
       </p:sp>
       <p:grpSp>
         <p:nvGrpSpPr>
-          <p:cNvPr id="131" name="Группа 8"/>
+          <p:cNvPr id="130" name="Группа 8"/>
           <p:cNvGrpSpPr/>
           <p:nvPr/>
         </p:nvGrpSpPr>
@@ -8892,7 +8482,7 @@
         </p:grpSpPr>
         <p:sp>
           <p:nvSpPr>
-            <p:cNvPr id="132" name="Прямая соединительная линия 7"/>
+            <p:cNvPr id="131" name="Прямая соединительная линия 7"/>
             <p:cNvSpPr/>
             <p:nvPr/>
           </p:nvSpPr>
@@ -8925,7 +8515,7 @@
         </p:sp>
         <p:sp>
           <p:nvSpPr>
-            <p:cNvPr id="133" name="Прямая соединительная линия 22"/>
+            <p:cNvPr id="132" name="Прямая соединительная линия 22"/>
             <p:cNvSpPr/>
             <p:nvPr/>
           </p:nvSpPr>
@@ -8959,7 +8549,7 @@
       </p:grpSp>
       <p:grpSp>
         <p:nvGrpSpPr>
-          <p:cNvPr id="134" name="Группа 23"/>
+          <p:cNvPr id="133" name="Группа 23"/>
           <p:cNvGrpSpPr/>
           <p:nvPr/>
         </p:nvGrpSpPr>
@@ -8973,7 +8563,7 @@
         </p:grpSpPr>
         <p:sp>
           <p:nvSpPr>
-            <p:cNvPr id="135" name="Прямая соединительная линия 30"/>
+            <p:cNvPr id="134" name="Прямая соединительная линия 30"/>
             <p:cNvSpPr/>
             <p:nvPr/>
           </p:nvSpPr>
@@ -9006,7 +8596,7 @@
         </p:sp>
         <p:sp>
           <p:nvSpPr>
-            <p:cNvPr id="136" name="Прямая соединительная линия 31"/>
+            <p:cNvPr id="135" name="Прямая соединительная линия 31"/>
             <p:cNvSpPr/>
             <p:nvPr/>
           </p:nvSpPr>
@@ -9040,28 +8630,40 @@
       </p:grpSp>
       <p:sp>
         <p:nvSpPr>
-          <p:cNvPr id="137" name=""/>
-          <p:cNvSpPr txBox="1"/>
+          <p:cNvPr id="136" name=""/>
+          <p:cNvSpPr/>
           <p:nvPr/>
         </p:nvSpPr>
         <p:spPr>
           <a:xfrm>
             <a:off x="349200" y="264600"/>
-            <a:ext cx="8229600" cy="346320"/>
-          </a:xfrm>
-          <a:prstGeom prst="rect">
-            <a:avLst/>
-          </a:prstGeom>
-          <a:noFill/>
-          <a:ln w="0">
-            <a:noFill/>
-          </a:ln>
-        </p:spPr>
+            <a:ext cx="8229240" cy="345960"/>
+          </a:xfrm>
+          <a:prstGeom prst="rect">
+            <a:avLst/>
+          </a:prstGeom>
+          <a:noFill/>
+          <a:ln w="0">
+            <a:noFill/>
+          </a:ln>
+        </p:spPr>
+        <p:style>
+          <a:lnRef idx="0"/>
+          <a:fillRef idx="0"/>
+          <a:effectRef idx="0"/>
+          <a:fontRef idx="minor"/>
+        </p:style>
         <p:txBody>
           <a:bodyPr lIns="90000" rIns="90000" tIns="45000" bIns="45000" anchor="t">
             <a:noAutofit/>
           </a:bodyPr>
           <a:p>
+            <a:pPr>
+              <a:lnSpc>
+                <a:spcPct val="100000"/>
+              </a:lnSpc>
+              <a:buNone/>
+            </a:pPr>
             <a:r>
               <a:rPr b="0" lang="en-US" sz="1800" spc="-1" strike="noStrike">
                 <a:latin typeface="Arial"/>
@@ -9113,14 +8715,14 @@
       </p:grpSpPr>
       <p:sp>
         <p:nvSpPr>
-          <p:cNvPr id="138" name="Прямоугольник со скругленными углами 3"/>
+          <p:cNvPr id="137" name="Прямоугольник со скругленными углами 3"/>
           <p:cNvSpPr/>
           <p:nvPr/>
         </p:nvSpPr>
         <p:spPr>
           <a:xfrm>
             <a:off x="5884200" y="0"/>
-            <a:ext cx="3259440" cy="5143320"/>
+            <a:ext cx="3259080" cy="5142960"/>
           </a:xfrm>
           <a:prstGeom prst="roundRect">
             <a:avLst>
@@ -9179,14 +8781,14 @@
       </p:sp>
       <p:sp>
         <p:nvSpPr>
-          <p:cNvPr id="139" name="Прямоугольник: скругленные углы 12"/>
+          <p:cNvPr id="138" name="Прямоугольник: скругленные углы 12"/>
           <p:cNvSpPr/>
           <p:nvPr/>
         </p:nvSpPr>
         <p:spPr>
           <a:xfrm>
             <a:off x="384840" y="3378240"/>
-            <a:ext cx="5236560" cy="1321200"/>
+            <a:ext cx="5236200" cy="1320840"/>
           </a:xfrm>
           <a:prstGeom prst="roundRect">
             <a:avLst>
@@ -9217,14 +8819,14 @@
       </p:sp>
       <p:sp>
         <p:nvSpPr>
-          <p:cNvPr id="140" name="Прямоугольник: скругленные углы 13"/>
+          <p:cNvPr id="139" name="Прямоугольник: скругленные углы 13"/>
           <p:cNvSpPr/>
           <p:nvPr/>
         </p:nvSpPr>
         <p:spPr>
           <a:xfrm>
             <a:off x="3091680" y="1135080"/>
-            <a:ext cx="2533320" cy="2057040"/>
+            <a:ext cx="2532960" cy="2056680"/>
           </a:xfrm>
           <a:prstGeom prst="roundRect">
             <a:avLst>
@@ -9255,14 +8857,14 @@
       </p:sp>
       <p:sp>
         <p:nvSpPr>
-          <p:cNvPr id="141" name="Прямоугольник: скругленные углы 14"/>
+          <p:cNvPr id="140" name="Прямоугольник: скругленные углы 14"/>
           <p:cNvSpPr/>
           <p:nvPr/>
         </p:nvSpPr>
         <p:spPr>
           <a:xfrm>
             <a:off x="387720" y="1120680"/>
-            <a:ext cx="2533320" cy="2057040"/>
+            <a:ext cx="2532960" cy="2056680"/>
           </a:xfrm>
           <a:prstGeom prst="roundRect">
             <a:avLst>
@@ -9293,14 +8895,14 @@
       </p:sp>
       <p:sp>
         <p:nvSpPr>
-          <p:cNvPr id="142" name="TextBox 10"/>
+          <p:cNvPr id="141" name="TextBox 10"/>
           <p:cNvSpPr/>
           <p:nvPr/>
         </p:nvSpPr>
         <p:spPr>
           <a:xfrm>
             <a:off x="476280" y="1176840"/>
-            <a:ext cx="2343600" cy="713880"/>
+            <a:ext cx="2343240" cy="713520"/>
           </a:xfrm>
           <a:prstGeom prst="rect">
             <a:avLst/>
@@ -9355,14 +8957,14 @@
       </p:sp>
       <p:sp>
         <p:nvSpPr>
-          <p:cNvPr id="143" name="TextBox 10"/>
+          <p:cNvPr id="142" name="TextBox 10"/>
           <p:cNvSpPr/>
           <p:nvPr/>
         </p:nvSpPr>
         <p:spPr>
           <a:xfrm>
             <a:off x="476280" y="1961280"/>
-            <a:ext cx="2343600" cy="1142280"/>
+            <a:ext cx="2343240" cy="1141920"/>
           </a:xfrm>
           <a:prstGeom prst="rect">
             <a:avLst/>
@@ -9417,14 +9019,14 @@
       </p:sp>
       <p:sp>
         <p:nvSpPr>
-          <p:cNvPr id="144" name="TextBox 10"/>
+          <p:cNvPr id="143" name="TextBox 10"/>
           <p:cNvSpPr/>
           <p:nvPr/>
         </p:nvSpPr>
         <p:spPr>
           <a:xfrm>
             <a:off x="3179880" y="1176840"/>
-            <a:ext cx="2340360" cy="713880"/>
+            <a:ext cx="2340000" cy="713520"/>
           </a:xfrm>
           <a:prstGeom prst="rect">
             <a:avLst/>
@@ -9469,14 +9071,14 @@
       </p:sp>
       <p:sp>
         <p:nvSpPr>
-          <p:cNvPr id="145" name="TextBox 10"/>
+          <p:cNvPr id="144" name="TextBox 10"/>
           <p:cNvSpPr/>
           <p:nvPr/>
         </p:nvSpPr>
         <p:spPr>
           <a:xfrm>
             <a:off x="3179880" y="1961280"/>
-            <a:ext cx="2340360" cy="1142280"/>
+            <a:ext cx="2340000" cy="1141920"/>
           </a:xfrm>
           <a:prstGeom prst="rect">
             <a:avLst/>
@@ -9531,14 +9133,14 @@
       </p:sp>
       <p:sp>
         <p:nvSpPr>
-          <p:cNvPr id="146" name="TextBox 10"/>
+          <p:cNvPr id="145" name="TextBox 10"/>
           <p:cNvSpPr/>
           <p:nvPr/>
         </p:nvSpPr>
         <p:spPr>
           <a:xfrm>
             <a:off x="476280" y="3479760"/>
-            <a:ext cx="5236560" cy="329040"/>
+            <a:ext cx="5236200" cy="328680"/>
           </a:xfrm>
           <a:prstGeom prst="rect">
             <a:avLst/>
@@ -9583,14 +9185,14 @@
       </p:sp>
       <p:sp>
         <p:nvSpPr>
-          <p:cNvPr id="147" name="TextBox 10"/>
+          <p:cNvPr id="146" name="TextBox 10"/>
           <p:cNvSpPr/>
           <p:nvPr/>
         </p:nvSpPr>
         <p:spPr>
           <a:xfrm>
             <a:off x="476280" y="3831480"/>
-            <a:ext cx="5146920" cy="713880"/>
+            <a:ext cx="5146560" cy="713520"/>
           </a:xfrm>
           <a:prstGeom prst="rect">
             <a:avLst/>
@@ -9645,14 +9247,14 @@
       </p:sp>
       <p:sp>
         <p:nvSpPr>
-          <p:cNvPr id="148" name="TextBox 20"/>
+          <p:cNvPr id="147" name="TextBox 20"/>
           <p:cNvSpPr/>
           <p:nvPr/>
         </p:nvSpPr>
         <p:spPr>
           <a:xfrm>
             <a:off x="338760" y="160560"/>
-            <a:ext cx="5282640" cy="927720"/>
+            <a:ext cx="5282280" cy="927360"/>
           </a:xfrm>
           <a:prstGeom prst="rect">
             <a:avLst/>
@@ -9685,6 +9287,7 @@
                   <a:srgbClr val="ffffff"/>
                 </a:solidFill>
                 <a:latin typeface="Arial"/>
+                <a:ea typeface="DejaVu Sans"/>
               </a:rPr>
               <a:t>TITLE</a:t>
             </a:r>

</xml_diff>